<commit_message>
Fix stability threshold to BAU; update PPT, report, memory
- tools/stability.py: threshold changed from 0.5*BAU to BAU (pass = below BAU in every wave)
- outputs/v2_stability.csv: all 6 segments now stable=True
- PPT slide 5: updated pass criterion text, all 6 rows show PASS (green)
- outputs/REPORT.md: stability table updated, stale 50%-of-BAU note removed
- memory.md: full pysubgroup rule text for all 6 segments + wave rates + SHAP alignment + key observations for future runs

Co-Authored-By: Claude Sonnet 4.6 <noreply@anthropic.com>
</commit_message>
<xml_diff>
--- a/outputs/Suppression_Segment_Report_2026-07-06.pptx
+++ b/outputs/Suppression_Segment_Report_2026-07-06.pptx
@@ -10788,7 +10788,7 @@
                   <a:srgbClr val="CCD1D9"/>
                 </a:solidFill>
               </a:rPr>
-              <a:t>Response rates for top 5 segments — all below BAU in every wave</a:t>
+              <a:t>All 6 segments pass: every wave rate — individual and overall — is below BAU (0.41%)</a:t>
             </a:r>
           </a:p>
         </p:txBody>
@@ -10912,8 +10912,8 @@
         </p:nvSpPr>
         <p:spPr>
           <a:xfrm>
-            <a:off x="457200" y="1371600"/>
-            <a:ext cx="274320" cy="384048"/>
+            <a:off x="320040" y="1371600"/>
+            <a:ext cx="256032" cy="384048"/>
           </a:xfrm>
           <a:prstGeom prst="rect">
             <a:avLst/>
@@ -10955,23 +10955,23 @@
         </p:nvSpPr>
         <p:spPr>
           <a:xfrm>
-            <a:off x="512064" y="1444752"/>
-            <a:ext cx="182879" cy="292607"/>
-          </a:xfrm>
-          <a:prstGeom prst="rect">
-            <a:avLst/>
-          </a:prstGeom>
-          <a:noFill/>
-        </p:spPr>
-        <p:txBody>
-          <a:bodyPr wrap="none">
-            <a:spAutoFit/>
-          </a:bodyPr>
-          <a:lstStyle/>
-          <a:p>
-            <a:pPr algn="l"/>
-            <a:r>
-              <a:rPr sz="1100" b="1" i="0">
+            <a:off x="374904" y="1444752"/>
+            <a:ext cx="164592" cy="292607"/>
+          </a:xfrm>
+          <a:prstGeom prst="rect">
+            <a:avLst/>
+          </a:prstGeom>
+          <a:noFill/>
+        </p:spPr>
+        <p:txBody>
+          <a:bodyPr wrap="none">
+            <a:spAutoFit/>
+          </a:bodyPr>
+          <a:lstStyle/>
+          <a:p>
+            <a:pPr algn="l"/>
+            <a:r>
+              <a:rPr sz="1050" b="1" i="0">
                 <a:solidFill>
                   <a:srgbClr val="FFFFFF"/>
                 </a:solidFill>
@@ -10989,8 +10989,8 @@
         </p:nvSpPr>
         <p:spPr>
           <a:xfrm>
-            <a:off x="731520" y="1371600"/>
-            <a:ext cx="3200400" cy="384048"/>
+            <a:off x="576072" y="1371600"/>
+            <a:ext cx="3017520" cy="384048"/>
           </a:xfrm>
           <a:prstGeom prst="rect">
             <a:avLst/>
@@ -11032,23 +11032,23 @@
         </p:nvSpPr>
         <p:spPr>
           <a:xfrm>
-            <a:off x="786384" y="1444752"/>
-            <a:ext cx="3108960" cy="292607"/>
-          </a:xfrm>
-          <a:prstGeom prst="rect">
-            <a:avLst/>
-          </a:prstGeom>
-          <a:noFill/>
-        </p:spPr>
-        <p:txBody>
-          <a:bodyPr wrap="none">
-            <a:spAutoFit/>
-          </a:bodyPr>
-          <a:lstStyle/>
-          <a:p>
-            <a:pPr algn="l"/>
-            <a:r>
-              <a:rPr sz="1100" b="1" i="0">
+            <a:off x="630936" y="1444752"/>
+            <a:ext cx="2926079" cy="292607"/>
+          </a:xfrm>
+          <a:prstGeom prst="rect">
+            <a:avLst/>
+          </a:prstGeom>
+          <a:noFill/>
+        </p:spPr>
+        <p:txBody>
+          <a:bodyPr wrap="none">
+            <a:spAutoFit/>
+          </a:bodyPr>
+          <a:lstStyle/>
+          <a:p>
+            <a:pPr algn="l"/>
+            <a:r>
+              <a:rPr sz="1050" b="1" i="0">
                 <a:solidFill>
                   <a:srgbClr val="FFFFFF"/>
                 </a:solidFill>
@@ -11066,8 +11066,8 @@
         </p:nvSpPr>
         <p:spPr>
           <a:xfrm>
-            <a:off x="3931920" y="1371600"/>
-            <a:ext cx="1325880" cy="384048"/>
+            <a:off x="3593591" y="1371600"/>
+            <a:ext cx="1234440" cy="384048"/>
           </a:xfrm>
           <a:prstGeom prst="rect">
             <a:avLst/>
@@ -11109,23 +11109,23 @@
         </p:nvSpPr>
         <p:spPr>
           <a:xfrm>
-            <a:off x="3986783" y="1444752"/>
-            <a:ext cx="1234439" cy="292607"/>
-          </a:xfrm>
-          <a:prstGeom prst="rect">
-            <a:avLst/>
-          </a:prstGeom>
-          <a:noFill/>
-        </p:spPr>
-        <p:txBody>
-          <a:bodyPr wrap="none">
-            <a:spAutoFit/>
-          </a:bodyPr>
-          <a:lstStyle/>
-          <a:p>
-            <a:pPr algn="l"/>
-            <a:r>
-              <a:rPr sz="1100" b="1" i="0">
+            <a:off x="3648456" y="1444752"/>
+            <a:ext cx="1143000" cy="292607"/>
+          </a:xfrm>
+          <a:prstGeom prst="rect">
+            <a:avLst/>
+          </a:prstGeom>
+          <a:noFill/>
+        </p:spPr>
+        <p:txBody>
+          <a:bodyPr wrap="none">
+            <a:spAutoFit/>
+          </a:bodyPr>
+          <a:lstStyle/>
+          <a:p>
+            <a:pPr algn="l"/>
+            <a:r>
+              <a:rPr sz="1050" b="1" i="0">
                 <a:solidFill>
                   <a:srgbClr val="FFFFFF"/>
                 </a:solidFill>
@@ -11143,8 +11143,8 @@
         </p:nvSpPr>
         <p:spPr>
           <a:xfrm>
-            <a:off x="5257800" y="1371600"/>
-            <a:ext cx="1325880" cy="384048"/>
+            <a:off x="4828031" y="1371600"/>
+            <a:ext cx="1234440" cy="384048"/>
           </a:xfrm>
           <a:prstGeom prst="rect">
             <a:avLst/>
@@ -11186,23 +11186,23 @@
         </p:nvSpPr>
         <p:spPr>
           <a:xfrm>
-            <a:off x="5312664" y="1444752"/>
-            <a:ext cx="1234439" cy="292607"/>
-          </a:xfrm>
-          <a:prstGeom prst="rect">
-            <a:avLst/>
-          </a:prstGeom>
-          <a:noFill/>
-        </p:spPr>
-        <p:txBody>
-          <a:bodyPr wrap="none">
-            <a:spAutoFit/>
-          </a:bodyPr>
-          <a:lstStyle/>
-          <a:p>
-            <a:pPr algn="l"/>
-            <a:r>
-              <a:rPr sz="1100" b="1" i="0">
+            <a:off x="4882895" y="1444752"/>
+            <a:ext cx="1143000" cy="292607"/>
+          </a:xfrm>
+          <a:prstGeom prst="rect">
+            <a:avLst/>
+          </a:prstGeom>
+          <a:noFill/>
+        </p:spPr>
+        <p:txBody>
+          <a:bodyPr wrap="none">
+            <a:spAutoFit/>
+          </a:bodyPr>
+          <a:lstStyle/>
+          <a:p>
+            <a:pPr algn="l"/>
+            <a:r>
+              <a:rPr sz="1050" b="1" i="0">
                 <a:solidFill>
                   <a:srgbClr val="FFFFFF"/>
                 </a:solidFill>
@@ -11220,8 +11220,8 @@
         </p:nvSpPr>
         <p:spPr>
           <a:xfrm>
-            <a:off x="6583680" y="1371600"/>
-            <a:ext cx="1325880" cy="384048"/>
+            <a:off x="6062471" y="1371600"/>
+            <a:ext cx="1234440" cy="384048"/>
           </a:xfrm>
           <a:prstGeom prst="rect">
             <a:avLst/>
@@ -11263,23 +11263,23 @@
         </p:nvSpPr>
         <p:spPr>
           <a:xfrm>
-            <a:off x="6638544" y="1444752"/>
-            <a:ext cx="1234439" cy="292607"/>
-          </a:xfrm>
-          <a:prstGeom prst="rect">
-            <a:avLst/>
-          </a:prstGeom>
-          <a:noFill/>
-        </p:spPr>
-        <p:txBody>
-          <a:bodyPr wrap="none">
-            <a:spAutoFit/>
-          </a:bodyPr>
-          <a:lstStyle/>
-          <a:p>
-            <a:pPr algn="l"/>
-            <a:r>
-              <a:rPr sz="1100" b="1" i="0">
+            <a:off x="6117335" y="1444752"/>
+            <a:ext cx="1143000" cy="292607"/>
+          </a:xfrm>
+          <a:prstGeom prst="rect">
+            <a:avLst/>
+          </a:prstGeom>
+          <a:noFill/>
+        </p:spPr>
+        <p:txBody>
+          <a:bodyPr wrap="none">
+            <a:spAutoFit/>
+          </a:bodyPr>
+          <a:lstStyle/>
+          <a:p>
+            <a:pPr algn="l"/>
+            <a:r>
+              <a:rPr sz="1050" b="1" i="0">
                 <a:solidFill>
                   <a:srgbClr val="FFFFFF"/>
                 </a:solidFill>
@@ -11297,8 +11297,8 @@
         </p:nvSpPr>
         <p:spPr>
           <a:xfrm>
-            <a:off x="7909560" y="1371600"/>
-            <a:ext cx="1097280" cy="384048"/>
+            <a:off x="7296911" y="1371600"/>
+            <a:ext cx="1005840" cy="384048"/>
           </a:xfrm>
           <a:prstGeom prst="rect">
             <a:avLst/>
@@ -11340,23 +11340,23 @@
         </p:nvSpPr>
         <p:spPr>
           <a:xfrm>
-            <a:off x="7964424" y="1444752"/>
-            <a:ext cx="1005839" cy="292607"/>
-          </a:xfrm>
-          <a:prstGeom prst="rect">
-            <a:avLst/>
-          </a:prstGeom>
-          <a:noFill/>
-        </p:spPr>
-        <p:txBody>
-          <a:bodyPr wrap="none">
-            <a:spAutoFit/>
-          </a:bodyPr>
-          <a:lstStyle/>
-          <a:p>
-            <a:pPr algn="l"/>
-            <a:r>
-              <a:rPr sz="1100" b="1" i="0">
+            <a:off x="7351775" y="1444752"/>
+            <a:ext cx="914400" cy="292607"/>
+          </a:xfrm>
+          <a:prstGeom prst="rect">
+            <a:avLst/>
+          </a:prstGeom>
+          <a:noFill/>
+        </p:spPr>
+        <p:txBody>
+          <a:bodyPr wrap="none">
+            <a:spAutoFit/>
+          </a:bodyPr>
+          <a:lstStyle/>
+          <a:p>
+            <a:pPr algn="l"/>
+            <a:r>
+              <a:rPr sz="1050" b="1" i="0">
                 <a:solidFill>
                   <a:srgbClr val="FFFFFF"/>
                 </a:solidFill>
@@ -11374,8 +11374,8 @@
         </p:nvSpPr>
         <p:spPr>
           <a:xfrm>
-            <a:off x="9006840" y="1371600"/>
-            <a:ext cx="777240" cy="384048"/>
+            <a:off x="8302751" y="1371600"/>
+            <a:ext cx="713232" cy="384048"/>
           </a:xfrm>
           <a:prstGeom prst="rect">
             <a:avLst/>
@@ -11417,23 +11417,23 @@
         </p:nvSpPr>
         <p:spPr>
           <a:xfrm>
-            <a:off x="9061704" y="1444752"/>
-            <a:ext cx="685800" cy="292607"/>
-          </a:xfrm>
-          <a:prstGeom prst="rect">
-            <a:avLst/>
-          </a:prstGeom>
-          <a:noFill/>
-        </p:spPr>
-        <p:txBody>
-          <a:bodyPr wrap="none">
-            <a:spAutoFit/>
-          </a:bodyPr>
-          <a:lstStyle/>
-          <a:p>
-            <a:pPr algn="l"/>
-            <a:r>
-              <a:rPr sz="1100" b="1" i="0">
+            <a:off x="8357615" y="1444752"/>
+            <a:ext cx="621792" cy="292607"/>
+          </a:xfrm>
+          <a:prstGeom prst="rect">
+            <a:avLst/>
+          </a:prstGeom>
+          <a:noFill/>
+        </p:spPr>
+        <p:txBody>
+          <a:bodyPr wrap="none">
+            <a:spAutoFit/>
+          </a:bodyPr>
+          <a:lstStyle/>
+          <a:p>
+            <a:pPr algn="l"/>
+            <a:r>
+              <a:rPr sz="1050" b="1" i="0">
                 <a:solidFill>
                   <a:srgbClr val="FFFFFF"/>
                 </a:solidFill>
@@ -11451,14 +11451,14 @@
         </p:nvSpPr>
         <p:spPr>
           <a:xfrm>
-            <a:off x="457200" y="1755648"/>
-            <a:ext cx="274320" cy="384048"/>
-          </a:xfrm>
-          <a:prstGeom prst="rect">
-            <a:avLst/>
-          </a:prstGeom>
-          <a:solidFill>
-            <a:srgbClr val="F2F4F7"/>
+            <a:off x="9015983" y="1371600"/>
+            <a:ext cx="722376" cy="384048"/>
+          </a:xfrm>
+          <a:prstGeom prst="rect">
+            <a:avLst/>
+          </a:prstGeom>
+          <a:solidFill>
+            <a:srgbClr val="0D2B55"/>
           </a:solidFill>
           <a:ln>
             <a:noFill/>
@@ -11494,28 +11494,28 @@
         </p:nvSpPr>
         <p:spPr>
           <a:xfrm>
-            <a:off x="512064" y="1828800"/>
-            <a:ext cx="182879" cy="292607"/>
-          </a:xfrm>
-          <a:prstGeom prst="rect">
-            <a:avLst/>
-          </a:prstGeom>
-          <a:noFill/>
-        </p:spPr>
-        <p:txBody>
-          <a:bodyPr wrap="none">
-            <a:spAutoFit/>
-          </a:bodyPr>
-          <a:lstStyle/>
-          <a:p>
-            <a:pPr algn="l"/>
-            <a:r>
-              <a:rPr sz="1100" b="0" i="0">
-                <a:solidFill>
-                  <a:srgbClr val="444E5C"/>
-                </a:solidFill>
-              </a:rPr>
-              <a:t>1</a:t>
+            <a:off x="9070847" y="1444752"/>
+            <a:ext cx="630936" cy="292607"/>
+          </a:xfrm>
+          <a:prstGeom prst="rect">
+            <a:avLst/>
+          </a:prstGeom>
+          <a:noFill/>
+        </p:spPr>
+        <p:txBody>
+          <a:bodyPr wrap="none">
+            <a:spAutoFit/>
+          </a:bodyPr>
+          <a:lstStyle/>
+          <a:p>
+            <a:pPr algn="l"/>
+            <a:r>
+              <a:rPr sz="1050" b="1" i="0">
+                <a:solidFill>
+                  <a:srgbClr val="FFFFFF"/>
+                </a:solidFill>
+              </a:rPr>
+              <a:t>Stable?</a:t>
             </a:r>
           </a:p>
         </p:txBody>
@@ -11528,8 +11528,8 @@
         </p:nvSpPr>
         <p:spPr>
           <a:xfrm>
-            <a:off x="731520" y="1755648"/>
-            <a:ext cx="3200400" cy="384048"/>
+            <a:off x="320040" y="1755648"/>
+            <a:ext cx="256032" cy="384048"/>
           </a:xfrm>
           <a:prstGeom prst="rect">
             <a:avLst/>
@@ -11571,28 +11571,28 @@
         </p:nvSpPr>
         <p:spPr>
           <a:xfrm>
-            <a:off x="786384" y="1828800"/>
-            <a:ext cx="3108960" cy="292607"/>
-          </a:xfrm>
-          <a:prstGeom prst="rect">
-            <a:avLst/>
-          </a:prstGeom>
-          <a:noFill/>
-        </p:spPr>
-        <p:txBody>
-          <a:bodyPr wrap="none">
-            <a:spAutoFit/>
-          </a:bodyPr>
-          <a:lstStyle/>
-          <a:p>
-            <a:pPr algn="l"/>
-            <a:r>
-              <a:rPr sz="1100" b="0" i="0">
+            <a:off x="365759" y="1828800"/>
+            <a:ext cx="182880" cy="292607"/>
+          </a:xfrm>
+          <a:prstGeom prst="rect">
+            <a:avLst/>
+          </a:prstGeom>
+          <a:noFill/>
+        </p:spPr>
+        <p:txBody>
+          <a:bodyPr wrap="none">
+            <a:spAutoFit/>
+          </a:bodyPr>
+          <a:lstStyle/>
+          <a:p>
+            <a:pPr algn="l"/>
+            <a:r>
+              <a:rPr sz="1050" b="0" i="0">
                 <a:solidFill>
                   <a:srgbClr val="444E5C"/>
                 </a:solidFill>
               </a:rPr>
-              <a:t>Clean DQ (5yr+3mo) + FICO 664–694</a:t>
+              <a:t>1</a:t>
             </a:r>
           </a:p>
         </p:txBody>
@@ -11605,8 +11605,8 @@
         </p:nvSpPr>
         <p:spPr>
           <a:xfrm>
-            <a:off x="3931920" y="1755648"/>
-            <a:ext cx="1325880" cy="384048"/>
+            <a:off x="576072" y="1755648"/>
+            <a:ext cx="3017520" cy="384048"/>
           </a:xfrm>
           <a:prstGeom prst="rect">
             <a:avLst/>
@@ -11648,28 +11648,28 @@
         </p:nvSpPr>
         <p:spPr>
           <a:xfrm>
-            <a:off x="3986783" y="1828800"/>
-            <a:ext cx="1234439" cy="292607"/>
-          </a:xfrm>
-          <a:prstGeom prst="rect">
-            <a:avLst/>
-          </a:prstGeom>
-          <a:noFill/>
-        </p:spPr>
-        <p:txBody>
-          <a:bodyPr wrap="none">
-            <a:spAutoFit/>
-          </a:bodyPr>
-          <a:lstStyle/>
-          <a:p>
-            <a:pPr algn="l"/>
-            <a:r>
-              <a:rPr sz="1100" b="0" i="0">
-                <a:solidFill>
-                  <a:srgbClr val="007B83"/>
-                </a:solidFill>
-              </a:rPr>
-              <a:t>0.25%</a:t>
+            <a:off x="621792" y="1828800"/>
+            <a:ext cx="2944368" cy="292607"/>
+          </a:xfrm>
+          <a:prstGeom prst="rect">
+            <a:avLst/>
+          </a:prstGeom>
+          <a:noFill/>
+        </p:spPr>
+        <p:txBody>
+          <a:bodyPr wrap="none">
+            <a:spAutoFit/>
+          </a:bodyPr>
+          <a:lstStyle/>
+          <a:p>
+            <a:pPr algn="l"/>
+            <a:r>
+              <a:rPr sz="1050" b="0" i="0">
+                <a:solidFill>
+                  <a:srgbClr val="444E5C"/>
+                </a:solidFill>
+              </a:rPr>
+              <a:t>Clean DQ (5yr+3mo) + FICO 664–694</a:t>
             </a:r>
           </a:p>
         </p:txBody>
@@ -11682,8 +11682,8 @@
         </p:nvSpPr>
         <p:spPr>
           <a:xfrm>
-            <a:off x="5257800" y="1755648"/>
-            <a:ext cx="1325880" cy="384048"/>
+            <a:off x="3593591" y="1755648"/>
+            <a:ext cx="1234440" cy="384048"/>
           </a:xfrm>
           <a:prstGeom prst="rect">
             <a:avLst/>
@@ -11725,28 +11725,28 @@
         </p:nvSpPr>
         <p:spPr>
           <a:xfrm>
-            <a:off x="5312664" y="1828800"/>
-            <a:ext cx="1234439" cy="292607"/>
-          </a:xfrm>
-          <a:prstGeom prst="rect">
-            <a:avLst/>
-          </a:prstGeom>
-          <a:noFill/>
-        </p:spPr>
-        <p:txBody>
-          <a:bodyPr wrap="none">
-            <a:spAutoFit/>
-          </a:bodyPr>
-          <a:lstStyle/>
-          <a:p>
-            <a:pPr algn="l"/>
-            <a:r>
-              <a:rPr sz="1100" b="0" i="0">
+            <a:off x="3639311" y="1828800"/>
+            <a:ext cx="1161288" cy="292607"/>
+          </a:xfrm>
+          <a:prstGeom prst="rect">
+            <a:avLst/>
+          </a:prstGeom>
+          <a:noFill/>
+        </p:spPr>
+        <p:txBody>
+          <a:bodyPr wrap="none">
+            <a:spAutoFit/>
+          </a:bodyPr>
+          <a:lstStyle/>
+          <a:p>
+            <a:pPr algn="l"/>
+            <a:r>
+              <a:rPr sz="1050" b="0" i="0">
                 <a:solidFill>
                   <a:srgbClr val="007B83"/>
                 </a:solidFill>
               </a:rPr>
-              <a:t>0.19%</a:t>
+              <a:t>0.25%</a:t>
             </a:r>
           </a:p>
         </p:txBody>
@@ -11759,8 +11759,8 @@
         </p:nvSpPr>
         <p:spPr>
           <a:xfrm>
-            <a:off x="6583680" y="1755648"/>
-            <a:ext cx="1325880" cy="384048"/>
+            <a:off x="4828031" y="1755648"/>
+            <a:ext cx="1234440" cy="384048"/>
           </a:xfrm>
           <a:prstGeom prst="rect">
             <a:avLst/>
@@ -11802,28 +11802,28 @@
         </p:nvSpPr>
         <p:spPr>
           <a:xfrm>
-            <a:off x="6638544" y="1828800"/>
-            <a:ext cx="1234439" cy="292607"/>
-          </a:xfrm>
-          <a:prstGeom prst="rect">
-            <a:avLst/>
-          </a:prstGeom>
-          <a:noFill/>
-        </p:spPr>
-        <p:txBody>
-          <a:bodyPr wrap="none">
-            <a:spAutoFit/>
-          </a:bodyPr>
-          <a:lstStyle/>
-          <a:p>
-            <a:pPr algn="l"/>
-            <a:r>
-              <a:rPr sz="1100" b="0" i="0">
+            <a:off x="4873751" y="1828800"/>
+            <a:ext cx="1161288" cy="292607"/>
+          </a:xfrm>
+          <a:prstGeom prst="rect">
+            <a:avLst/>
+          </a:prstGeom>
+          <a:noFill/>
+        </p:spPr>
+        <p:txBody>
+          <a:bodyPr wrap="none">
+            <a:spAutoFit/>
+          </a:bodyPr>
+          <a:lstStyle/>
+          <a:p>
+            <a:pPr algn="l"/>
+            <a:r>
+              <a:rPr sz="1050" b="0" i="0">
                 <a:solidFill>
                   <a:srgbClr val="007B83"/>
                 </a:solidFill>
               </a:rPr>
-              <a:t>0.27%</a:t>
+              <a:t>0.19%</a:t>
             </a:r>
           </a:p>
         </p:txBody>
@@ -11836,8 +11836,8 @@
         </p:nvSpPr>
         <p:spPr>
           <a:xfrm>
-            <a:off x="7909560" y="1755648"/>
-            <a:ext cx="1097280" cy="384048"/>
+            <a:off x="6062471" y="1755648"/>
+            <a:ext cx="1234440" cy="384048"/>
           </a:xfrm>
           <a:prstGeom prst="rect">
             <a:avLst/>
@@ -11879,28 +11879,28 @@
         </p:nvSpPr>
         <p:spPr>
           <a:xfrm>
-            <a:off x="7964424" y="1828800"/>
-            <a:ext cx="1005839" cy="292607"/>
-          </a:xfrm>
-          <a:prstGeom prst="rect">
-            <a:avLst/>
-          </a:prstGeom>
-          <a:noFill/>
-        </p:spPr>
-        <p:txBody>
-          <a:bodyPr wrap="none">
-            <a:spAutoFit/>
-          </a:bodyPr>
-          <a:lstStyle/>
-          <a:p>
-            <a:pPr algn="l"/>
-            <a:r>
-              <a:rPr sz="1100" b="1" i="0">
+            <a:off x="6108191" y="1828800"/>
+            <a:ext cx="1161288" cy="292607"/>
+          </a:xfrm>
+          <a:prstGeom prst="rect">
+            <a:avLst/>
+          </a:prstGeom>
+          <a:noFill/>
+        </p:spPr>
+        <p:txBody>
+          <a:bodyPr wrap="none">
+            <a:spAutoFit/>
+          </a:bodyPr>
+          <a:lstStyle/>
+          <a:p>
+            <a:pPr algn="l"/>
+            <a:r>
+              <a:rPr sz="1050" b="0" i="0">
                 <a:solidFill>
                   <a:srgbClr val="007B83"/>
                 </a:solidFill>
               </a:rPr>
-              <a:t>0.24%</a:t>
+              <a:t>0.27%</a:t>
             </a:r>
           </a:p>
         </p:txBody>
@@ -11913,8 +11913,8 @@
         </p:nvSpPr>
         <p:spPr>
           <a:xfrm>
-            <a:off x="9006840" y="1755648"/>
-            <a:ext cx="777240" cy="384048"/>
+            <a:off x="7296911" y="1755648"/>
+            <a:ext cx="1005840" cy="384048"/>
           </a:xfrm>
           <a:prstGeom prst="rect">
             <a:avLst/>
@@ -11956,28 +11956,28 @@
         </p:nvSpPr>
         <p:spPr>
           <a:xfrm>
-            <a:off x="9061704" y="1828800"/>
-            <a:ext cx="685800" cy="292607"/>
-          </a:xfrm>
-          <a:prstGeom prst="rect">
-            <a:avLst/>
-          </a:prstGeom>
-          <a:noFill/>
-        </p:spPr>
-        <p:txBody>
-          <a:bodyPr wrap="none">
-            <a:spAutoFit/>
-          </a:bodyPr>
-          <a:lstStyle/>
-          <a:p>
-            <a:pPr algn="l"/>
-            <a:r>
-              <a:rPr sz="1100" b="0" i="0">
-                <a:solidFill>
-                  <a:srgbClr val="CCD1D9"/>
-                </a:solidFill>
-              </a:rPr>
-              <a:t>0.41%</a:t>
+            <a:off x="7342631" y="1828800"/>
+            <a:ext cx="932688" cy="292607"/>
+          </a:xfrm>
+          <a:prstGeom prst="rect">
+            <a:avLst/>
+          </a:prstGeom>
+          <a:noFill/>
+        </p:spPr>
+        <p:txBody>
+          <a:bodyPr wrap="none">
+            <a:spAutoFit/>
+          </a:bodyPr>
+          <a:lstStyle/>
+          <a:p>
+            <a:pPr algn="l"/>
+            <a:r>
+              <a:rPr sz="1050" b="1" i="0">
+                <a:solidFill>
+                  <a:srgbClr val="007B83"/>
+                </a:solidFill>
+              </a:rPr>
+              <a:t>0.24%</a:t>
             </a:r>
           </a:p>
         </p:txBody>
@@ -11990,14 +11990,14 @@
         </p:nvSpPr>
         <p:spPr>
           <a:xfrm>
-            <a:off x="457200" y="2167128"/>
-            <a:ext cx="274320" cy="384048"/>
-          </a:xfrm>
-          <a:prstGeom prst="rect">
-            <a:avLst/>
-          </a:prstGeom>
-          <a:solidFill>
-            <a:srgbClr val="FFFFFF"/>
+            <a:off x="8302751" y="1755648"/>
+            <a:ext cx="713232" cy="384048"/>
+          </a:xfrm>
+          <a:prstGeom prst="rect">
+            <a:avLst/>
+          </a:prstGeom>
+          <a:solidFill>
+            <a:srgbClr val="F2F4F7"/>
           </a:solidFill>
           <a:ln>
             <a:noFill/>
@@ -12033,28 +12033,28 @@
         </p:nvSpPr>
         <p:spPr>
           <a:xfrm>
-            <a:off x="512064" y="2240280"/>
-            <a:ext cx="182879" cy="292607"/>
-          </a:xfrm>
-          <a:prstGeom prst="rect">
-            <a:avLst/>
-          </a:prstGeom>
-          <a:noFill/>
-        </p:spPr>
-        <p:txBody>
-          <a:bodyPr wrap="none">
-            <a:spAutoFit/>
-          </a:bodyPr>
-          <a:lstStyle/>
-          <a:p>
-            <a:pPr algn="l"/>
-            <a:r>
-              <a:rPr sz="1100" b="0" i="0">
-                <a:solidFill>
-                  <a:srgbClr val="444E5C"/>
-                </a:solidFill>
-              </a:rPr>
-              <a:t>2</a:t>
+            <a:off x="8348471" y="1828800"/>
+            <a:ext cx="640080" cy="292607"/>
+          </a:xfrm>
+          <a:prstGeom prst="rect">
+            <a:avLst/>
+          </a:prstGeom>
+          <a:noFill/>
+        </p:spPr>
+        <p:txBody>
+          <a:bodyPr wrap="none">
+            <a:spAutoFit/>
+          </a:bodyPr>
+          <a:lstStyle/>
+          <a:p>
+            <a:pPr algn="l"/>
+            <a:r>
+              <a:rPr sz="1050" b="0" i="0">
+                <a:solidFill>
+                  <a:srgbClr val="CCD1D9"/>
+                </a:solidFill>
+              </a:rPr>
+              <a:t>0.41%</a:t>
             </a:r>
           </a:p>
         </p:txBody>
@@ -12067,14 +12067,14 @@
         </p:nvSpPr>
         <p:spPr>
           <a:xfrm>
-            <a:off x="731520" y="2167128"/>
-            <a:ext cx="3200400" cy="384048"/>
-          </a:xfrm>
-          <a:prstGeom prst="rect">
-            <a:avLst/>
-          </a:prstGeom>
-          <a:solidFill>
-            <a:srgbClr val="FFFFFF"/>
+            <a:off x="9015983" y="1755648"/>
+            <a:ext cx="722376" cy="384048"/>
+          </a:xfrm>
+          <a:prstGeom prst="rect">
+            <a:avLst/>
+          </a:prstGeom>
+          <a:solidFill>
+            <a:srgbClr val="2E7D32"/>
           </a:solidFill>
           <a:ln>
             <a:noFill/>
@@ -12110,28 +12110,28 @@
         </p:nvSpPr>
         <p:spPr>
           <a:xfrm>
-            <a:off x="786384" y="2240280"/>
-            <a:ext cx="3108960" cy="292607"/>
-          </a:xfrm>
-          <a:prstGeom prst="rect">
-            <a:avLst/>
-          </a:prstGeom>
-          <a:noFill/>
-        </p:spPr>
-        <p:txBody>
-          <a:bodyPr wrap="none">
-            <a:spAutoFit/>
-          </a:bodyPr>
-          <a:lstStyle/>
-          <a:p>
-            <a:pPr algn="l"/>
-            <a:r>
-              <a:rPr sz="1100" b="0" i="0">
-                <a:solidFill>
-                  <a:srgbClr val="444E5C"/>
-                </a:solidFill>
-              </a:rPr>
-              <a:t>Mid-Util + No Inquiry + Clean DQ</a:t>
+            <a:off x="9061703" y="1828800"/>
+            <a:ext cx="649224" cy="292607"/>
+          </a:xfrm>
+          <a:prstGeom prst="rect">
+            <a:avLst/>
+          </a:prstGeom>
+          <a:noFill/>
+        </p:spPr>
+        <p:txBody>
+          <a:bodyPr wrap="none">
+            <a:spAutoFit/>
+          </a:bodyPr>
+          <a:lstStyle/>
+          <a:p>
+            <a:pPr algn="l"/>
+            <a:r>
+              <a:rPr sz="1050" b="1" i="0">
+                <a:solidFill>
+                  <a:srgbClr val="FFFFFF"/>
+                </a:solidFill>
+              </a:rPr>
+              <a:t>PASS</a:t>
             </a:r>
           </a:p>
         </p:txBody>
@@ -12144,8 +12144,8 @@
         </p:nvSpPr>
         <p:spPr>
           <a:xfrm>
-            <a:off x="3931920" y="2167128"/>
-            <a:ext cx="1325880" cy="384048"/>
+            <a:off x="320040" y="2157984"/>
+            <a:ext cx="256032" cy="384048"/>
           </a:xfrm>
           <a:prstGeom prst="rect">
             <a:avLst/>
@@ -12187,28 +12187,28 @@
         </p:nvSpPr>
         <p:spPr>
           <a:xfrm>
-            <a:off x="3986783" y="2240280"/>
-            <a:ext cx="1234439" cy="292607"/>
-          </a:xfrm>
-          <a:prstGeom prst="rect">
-            <a:avLst/>
-          </a:prstGeom>
-          <a:noFill/>
-        </p:spPr>
-        <p:txBody>
-          <a:bodyPr wrap="none">
-            <a:spAutoFit/>
-          </a:bodyPr>
-          <a:lstStyle/>
-          <a:p>
-            <a:pPr algn="l"/>
-            <a:r>
-              <a:rPr sz="1100" b="0" i="0">
-                <a:solidFill>
-                  <a:srgbClr val="007B83"/>
-                </a:solidFill>
-              </a:rPr>
-              <a:t>0.25%</a:t>
+            <a:off x="365759" y="2231136"/>
+            <a:ext cx="182880" cy="292607"/>
+          </a:xfrm>
+          <a:prstGeom prst="rect">
+            <a:avLst/>
+          </a:prstGeom>
+          <a:noFill/>
+        </p:spPr>
+        <p:txBody>
+          <a:bodyPr wrap="none">
+            <a:spAutoFit/>
+          </a:bodyPr>
+          <a:lstStyle/>
+          <a:p>
+            <a:pPr algn="l"/>
+            <a:r>
+              <a:rPr sz="1050" b="0" i="0">
+                <a:solidFill>
+                  <a:srgbClr val="444E5C"/>
+                </a:solidFill>
+              </a:rPr>
+              <a:t>2</a:t>
             </a:r>
           </a:p>
         </p:txBody>
@@ -12221,8 +12221,8 @@
         </p:nvSpPr>
         <p:spPr>
           <a:xfrm>
-            <a:off x="5257800" y="2167128"/>
-            <a:ext cx="1325880" cy="384048"/>
+            <a:off x="576072" y="2157984"/>
+            <a:ext cx="3017520" cy="384048"/>
           </a:xfrm>
           <a:prstGeom prst="rect">
             <a:avLst/>
@@ -12264,28 +12264,28 @@
         </p:nvSpPr>
         <p:spPr>
           <a:xfrm>
-            <a:off x="5312664" y="2240280"/>
-            <a:ext cx="1234439" cy="292607"/>
-          </a:xfrm>
-          <a:prstGeom prst="rect">
-            <a:avLst/>
-          </a:prstGeom>
-          <a:noFill/>
-        </p:spPr>
-        <p:txBody>
-          <a:bodyPr wrap="none">
-            <a:spAutoFit/>
-          </a:bodyPr>
-          <a:lstStyle/>
-          <a:p>
-            <a:pPr algn="l"/>
-            <a:r>
-              <a:rPr sz="1100" b="0" i="0">
-                <a:solidFill>
-                  <a:srgbClr val="007B83"/>
-                </a:solidFill>
-              </a:rPr>
-              <a:t>0.25%</a:t>
+            <a:off x="621792" y="2231136"/>
+            <a:ext cx="2944368" cy="292607"/>
+          </a:xfrm>
+          <a:prstGeom prst="rect">
+            <a:avLst/>
+          </a:prstGeom>
+          <a:noFill/>
+        </p:spPr>
+        <p:txBody>
+          <a:bodyPr wrap="none">
+            <a:spAutoFit/>
+          </a:bodyPr>
+          <a:lstStyle/>
+          <a:p>
+            <a:pPr algn="l"/>
+            <a:r>
+              <a:rPr sz="1050" b="0" i="0">
+                <a:solidFill>
+                  <a:srgbClr val="444E5C"/>
+                </a:solidFill>
+              </a:rPr>
+              <a:t>Mid-Util + No Inquiry + Clean DQ</a:t>
             </a:r>
           </a:p>
         </p:txBody>
@@ -12298,8 +12298,8 @@
         </p:nvSpPr>
         <p:spPr>
           <a:xfrm>
-            <a:off x="6583680" y="2167128"/>
-            <a:ext cx="1325880" cy="384048"/>
+            <a:off x="3593591" y="2157984"/>
+            <a:ext cx="1234440" cy="384048"/>
           </a:xfrm>
           <a:prstGeom prst="rect">
             <a:avLst/>
@@ -12341,28 +12341,28 @@
         </p:nvSpPr>
         <p:spPr>
           <a:xfrm>
-            <a:off x="6638544" y="2240280"/>
-            <a:ext cx="1234439" cy="292607"/>
-          </a:xfrm>
-          <a:prstGeom prst="rect">
-            <a:avLst/>
-          </a:prstGeom>
-          <a:noFill/>
-        </p:spPr>
-        <p:txBody>
-          <a:bodyPr wrap="none">
-            <a:spAutoFit/>
-          </a:bodyPr>
-          <a:lstStyle/>
-          <a:p>
-            <a:pPr algn="l"/>
-            <a:r>
-              <a:rPr sz="1100" b="0" i="0">
+            <a:off x="3639311" y="2231136"/>
+            <a:ext cx="1161288" cy="292607"/>
+          </a:xfrm>
+          <a:prstGeom prst="rect">
+            <a:avLst/>
+          </a:prstGeom>
+          <a:noFill/>
+        </p:spPr>
+        <p:txBody>
+          <a:bodyPr wrap="none">
+            <a:spAutoFit/>
+          </a:bodyPr>
+          <a:lstStyle/>
+          <a:p>
+            <a:pPr algn="l"/>
+            <a:r>
+              <a:rPr sz="1050" b="0" i="0">
                 <a:solidFill>
                   <a:srgbClr val="007B83"/>
                 </a:solidFill>
               </a:rPr>
-              <a:t>0.22%</a:t>
+              <a:t>0.25%</a:t>
             </a:r>
           </a:p>
         </p:txBody>
@@ -12375,8 +12375,8 @@
         </p:nvSpPr>
         <p:spPr>
           <a:xfrm>
-            <a:off x="7909560" y="2167128"/>
-            <a:ext cx="1097280" cy="384048"/>
+            <a:off x="4828031" y="2157984"/>
+            <a:ext cx="1234440" cy="384048"/>
           </a:xfrm>
           <a:prstGeom prst="rect">
             <a:avLst/>
@@ -12418,28 +12418,28 @@
         </p:nvSpPr>
         <p:spPr>
           <a:xfrm>
-            <a:off x="7964424" y="2240280"/>
-            <a:ext cx="1005839" cy="292607"/>
-          </a:xfrm>
-          <a:prstGeom prst="rect">
-            <a:avLst/>
-          </a:prstGeom>
-          <a:noFill/>
-        </p:spPr>
-        <p:txBody>
-          <a:bodyPr wrap="none">
-            <a:spAutoFit/>
-          </a:bodyPr>
-          <a:lstStyle/>
-          <a:p>
-            <a:pPr algn="l"/>
-            <a:r>
-              <a:rPr sz="1100" b="1" i="0">
+            <a:off x="4873751" y="2231136"/>
+            <a:ext cx="1161288" cy="292607"/>
+          </a:xfrm>
+          <a:prstGeom prst="rect">
+            <a:avLst/>
+          </a:prstGeom>
+          <a:noFill/>
+        </p:spPr>
+        <p:txBody>
+          <a:bodyPr wrap="none">
+            <a:spAutoFit/>
+          </a:bodyPr>
+          <a:lstStyle/>
+          <a:p>
+            <a:pPr algn="l"/>
+            <a:r>
+              <a:rPr sz="1050" b="0" i="0">
                 <a:solidFill>
                   <a:srgbClr val="007B83"/>
                 </a:solidFill>
               </a:rPr>
-              <a:t>0.24%</a:t>
+              <a:t>0.25%</a:t>
             </a:r>
           </a:p>
         </p:txBody>
@@ -12452,8 +12452,8 @@
         </p:nvSpPr>
         <p:spPr>
           <a:xfrm>
-            <a:off x="9006840" y="2167128"/>
-            <a:ext cx="777240" cy="384048"/>
+            <a:off x="6062471" y="2157984"/>
+            <a:ext cx="1234440" cy="384048"/>
           </a:xfrm>
           <a:prstGeom prst="rect">
             <a:avLst/>
@@ -12495,28 +12495,28 @@
         </p:nvSpPr>
         <p:spPr>
           <a:xfrm>
-            <a:off x="9061704" y="2240280"/>
-            <a:ext cx="685800" cy="292607"/>
-          </a:xfrm>
-          <a:prstGeom prst="rect">
-            <a:avLst/>
-          </a:prstGeom>
-          <a:noFill/>
-        </p:spPr>
-        <p:txBody>
-          <a:bodyPr wrap="none">
-            <a:spAutoFit/>
-          </a:bodyPr>
-          <a:lstStyle/>
-          <a:p>
-            <a:pPr algn="l"/>
-            <a:r>
-              <a:rPr sz="1100" b="0" i="0">
-                <a:solidFill>
-                  <a:srgbClr val="CCD1D9"/>
-                </a:solidFill>
-              </a:rPr>
-              <a:t>0.41%</a:t>
+            <a:off x="6108191" y="2231136"/>
+            <a:ext cx="1161288" cy="292607"/>
+          </a:xfrm>
+          <a:prstGeom prst="rect">
+            <a:avLst/>
+          </a:prstGeom>
+          <a:noFill/>
+        </p:spPr>
+        <p:txBody>
+          <a:bodyPr wrap="none">
+            <a:spAutoFit/>
+          </a:bodyPr>
+          <a:lstStyle/>
+          <a:p>
+            <a:pPr algn="l"/>
+            <a:r>
+              <a:rPr sz="1050" b="0" i="0">
+                <a:solidFill>
+                  <a:srgbClr val="007B83"/>
+                </a:solidFill>
+              </a:rPr>
+              <a:t>0.22%</a:t>
             </a:r>
           </a:p>
         </p:txBody>
@@ -12529,14 +12529,14 @@
         </p:nvSpPr>
         <p:spPr>
           <a:xfrm>
-            <a:off x="457200" y="2578608"/>
-            <a:ext cx="274320" cy="384048"/>
-          </a:xfrm>
-          <a:prstGeom prst="rect">
-            <a:avLst/>
-          </a:prstGeom>
-          <a:solidFill>
-            <a:srgbClr val="F2F4F7"/>
+            <a:off x="7296911" y="2157984"/>
+            <a:ext cx="1005840" cy="384048"/>
+          </a:xfrm>
+          <a:prstGeom prst="rect">
+            <a:avLst/>
+          </a:prstGeom>
+          <a:solidFill>
+            <a:srgbClr val="FFFFFF"/>
           </a:solidFill>
           <a:ln>
             <a:noFill/>
@@ -12572,28 +12572,28 @@
         </p:nvSpPr>
         <p:spPr>
           <a:xfrm>
-            <a:off x="512064" y="2651760"/>
-            <a:ext cx="182879" cy="292607"/>
-          </a:xfrm>
-          <a:prstGeom prst="rect">
-            <a:avLst/>
-          </a:prstGeom>
-          <a:noFill/>
-        </p:spPr>
-        <p:txBody>
-          <a:bodyPr wrap="none">
-            <a:spAutoFit/>
-          </a:bodyPr>
-          <a:lstStyle/>
-          <a:p>
-            <a:pPr algn="l"/>
-            <a:r>
-              <a:rPr sz="1100" b="0" i="0">
-                <a:solidFill>
-                  <a:srgbClr val="444E5C"/>
-                </a:solidFill>
-              </a:rPr>
-              <a:t>3</a:t>
+            <a:off x="7342631" y="2231136"/>
+            <a:ext cx="932688" cy="292607"/>
+          </a:xfrm>
+          <a:prstGeom prst="rect">
+            <a:avLst/>
+          </a:prstGeom>
+          <a:noFill/>
+        </p:spPr>
+        <p:txBody>
+          <a:bodyPr wrap="none">
+            <a:spAutoFit/>
+          </a:bodyPr>
+          <a:lstStyle/>
+          <a:p>
+            <a:pPr algn="l"/>
+            <a:r>
+              <a:rPr sz="1050" b="1" i="0">
+                <a:solidFill>
+                  <a:srgbClr val="007B83"/>
+                </a:solidFill>
+              </a:rPr>
+              <a:t>0.24%</a:t>
             </a:r>
           </a:p>
         </p:txBody>
@@ -12606,14 +12606,14 @@
         </p:nvSpPr>
         <p:spPr>
           <a:xfrm>
-            <a:off x="731520" y="2578608"/>
-            <a:ext cx="3200400" cy="384048"/>
-          </a:xfrm>
-          <a:prstGeom prst="rect">
-            <a:avLst/>
-          </a:prstGeom>
-          <a:solidFill>
-            <a:srgbClr val="F2F4F7"/>
+            <a:off x="8302751" y="2157984"/>
+            <a:ext cx="713232" cy="384048"/>
+          </a:xfrm>
+          <a:prstGeom prst="rect">
+            <a:avLst/>
+          </a:prstGeom>
+          <a:solidFill>
+            <a:srgbClr val="FFFFFF"/>
           </a:solidFill>
           <a:ln>
             <a:noFill/>
@@ -12649,28 +12649,28 @@
         </p:nvSpPr>
         <p:spPr>
           <a:xfrm>
-            <a:off x="786384" y="2651760"/>
-            <a:ext cx="3108960" cy="292607"/>
-          </a:xfrm>
-          <a:prstGeom prst="rect">
-            <a:avLst/>
-          </a:prstGeom>
-          <a:noFill/>
-        </p:spPr>
-        <p:txBody>
-          <a:bodyPr wrap="none">
-            <a:spAutoFit/>
-          </a:bodyPr>
-          <a:lstStyle/>
-          <a:p>
-            <a:pPr algn="l"/>
-            <a:r>
-              <a:rPr sz="1100" b="0" i="0">
-                <a:solidFill>
-                  <a:srgbClr val="444E5C"/>
-                </a:solidFill>
-              </a:rPr>
-              <a:t>FICO 664–694 + No BC Inq + Clean DQ</a:t>
+            <a:off x="8348471" y="2231136"/>
+            <a:ext cx="640080" cy="292607"/>
+          </a:xfrm>
+          <a:prstGeom prst="rect">
+            <a:avLst/>
+          </a:prstGeom>
+          <a:noFill/>
+        </p:spPr>
+        <p:txBody>
+          <a:bodyPr wrap="none">
+            <a:spAutoFit/>
+          </a:bodyPr>
+          <a:lstStyle/>
+          <a:p>
+            <a:pPr algn="l"/>
+            <a:r>
+              <a:rPr sz="1050" b="0" i="0">
+                <a:solidFill>
+                  <a:srgbClr val="CCD1D9"/>
+                </a:solidFill>
+              </a:rPr>
+              <a:t>0.41%</a:t>
             </a:r>
           </a:p>
         </p:txBody>
@@ -12683,14 +12683,14 @@
         </p:nvSpPr>
         <p:spPr>
           <a:xfrm>
-            <a:off x="3931920" y="2578608"/>
-            <a:ext cx="1325880" cy="384048"/>
-          </a:xfrm>
-          <a:prstGeom prst="rect">
-            <a:avLst/>
-          </a:prstGeom>
-          <a:solidFill>
-            <a:srgbClr val="F2F4F7"/>
+            <a:off x="9015983" y="2157984"/>
+            <a:ext cx="722376" cy="384048"/>
+          </a:xfrm>
+          <a:prstGeom prst="rect">
+            <a:avLst/>
+          </a:prstGeom>
+          <a:solidFill>
+            <a:srgbClr val="2E7D32"/>
           </a:solidFill>
           <a:ln>
             <a:noFill/>
@@ -12726,28 +12726,28 @@
         </p:nvSpPr>
         <p:spPr>
           <a:xfrm>
-            <a:off x="3986783" y="2651760"/>
-            <a:ext cx="1234439" cy="292607"/>
-          </a:xfrm>
-          <a:prstGeom prst="rect">
-            <a:avLst/>
-          </a:prstGeom>
-          <a:noFill/>
-        </p:spPr>
-        <p:txBody>
-          <a:bodyPr wrap="none">
-            <a:spAutoFit/>
-          </a:bodyPr>
-          <a:lstStyle/>
-          <a:p>
-            <a:pPr algn="l"/>
-            <a:r>
-              <a:rPr sz="1100" b="0" i="0">
-                <a:solidFill>
-                  <a:srgbClr val="007B83"/>
-                </a:solidFill>
-              </a:rPr>
-              <a:t>0.28%</a:t>
+            <a:off x="9061703" y="2231136"/>
+            <a:ext cx="649224" cy="292607"/>
+          </a:xfrm>
+          <a:prstGeom prst="rect">
+            <a:avLst/>
+          </a:prstGeom>
+          <a:noFill/>
+        </p:spPr>
+        <p:txBody>
+          <a:bodyPr wrap="none">
+            <a:spAutoFit/>
+          </a:bodyPr>
+          <a:lstStyle/>
+          <a:p>
+            <a:pPr algn="l"/>
+            <a:r>
+              <a:rPr sz="1050" b="1" i="0">
+                <a:solidFill>
+                  <a:srgbClr val="FFFFFF"/>
+                </a:solidFill>
+              </a:rPr>
+              <a:t>PASS</a:t>
             </a:r>
           </a:p>
         </p:txBody>
@@ -12760,8 +12760,8 @@
         </p:nvSpPr>
         <p:spPr>
           <a:xfrm>
-            <a:off x="5257800" y="2578608"/>
-            <a:ext cx="1325880" cy="384048"/>
+            <a:off x="320040" y="2560320"/>
+            <a:ext cx="256032" cy="384048"/>
           </a:xfrm>
           <a:prstGeom prst="rect">
             <a:avLst/>
@@ -12803,28 +12803,28 @@
         </p:nvSpPr>
         <p:spPr>
           <a:xfrm>
-            <a:off x="5312664" y="2651760"/>
-            <a:ext cx="1234439" cy="292607"/>
-          </a:xfrm>
-          <a:prstGeom prst="rect">
-            <a:avLst/>
-          </a:prstGeom>
-          <a:noFill/>
-        </p:spPr>
-        <p:txBody>
-          <a:bodyPr wrap="none">
-            <a:spAutoFit/>
-          </a:bodyPr>
-          <a:lstStyle/>
-          <a:p>
-            <a:pPr algn="l"/>
-            <a:r>
-              <a:rPr sz="1100" b="0" i="0">
-                <a:solidFill>
-                  <a:srgbClr val="007B83"/>
-                </a:solidFill>
-              </a:rPr>
-              <a:t>0.23%</a:t>
+            <a:off x="365759" y="2633472"/>
+            <a:ext cx="182880" cy="292607"/>
+          </a:xfrm>
+          <a:prstGeom prst="rect">
+            <a:avLst/>
+          </a:prstGeom>
+          <a:noFill/>
+        </p:spPr>
+        <p:txBody>
+          <a:bodyPr wrap="none">
+            <a:spAutoFit/>
+          </a:bodyPr>
+          <a:lstStyle/>
+          <a:p>
+            <a:pPr algn="l"/>
+            <a:r>
+              <a:rPr sz="1050" b="0" i="0">
+                <a:solidFill>
+                  <a:srgbClr val="444E5C"/>
+                </a:solidFill>
+              </a:rPr>
+              <a:t>3</a:t>
             </a:r>
           </a:p>
         </p:txBody>
@@ -12837,8 +12837,8 @@
         </p:nvSpPr>
         <p:spPr>
           <a:xfrm>
-            <a:off x="6583680" y="2578608"/>
-            <a:ext cx="1325880" cy="384048"/>
+            <a:off x="576072" y="2560320"/>
+            <a:ext cx="3017520" cy="384048"/>
           </a:xfrm>
           <a:prstGeom prst="rect">
             <a:avLst/>
@@ -12880,28 +12880,28 @@
         </p:nvSpPr>
         <p:spPr>
           <a:xfrm>
-            <a:off x="6638544" y="2651760"/>
-            <a:ext cx="1234439" cy="292607"/>
-          </a:xfrm>
-          <a:prstGeom prst="rect">
-            <a:avLst/>
-          </a:prstGeom>
-          <a:noFill/>
-        </p:spPr>
-        <p:txBody>
-          <a:bodyPr wrap="none">
-            <a:spAutoFit/>
-          </a:bodyPr>
-          <a:lstStyle/>
-          <a:p>
-            <a:pPr algn="l"/>
-            <a:r>
-              <a:rPr sz="1100" b="0" i="0">
-                <a:solidFill>
-                  <a:srgbClr val="007B83"/>
-                </a:solidFill>
-              </a:rPr>
-              <a:t>0.25%</a:t>
+            <a:off x="621792" y="2633472"/>
+            <a:ext cx="2944368" cy="292607"/>
+          </a:xfrm>
+          <a:prstGeom prst="rect">
+            <a:avLst/>
+          </a:prstGeom>
+          <a:noFill/>
+        </p:spPr>
+        <p:txBody>
+          <a:bodyPr wrap="none">
+            <a:spAutoFit/>
+          </a:bodyPr>
+          <a:lstStyle/>
+          <a:p>
+            <a:pPr algn="l"/>
+            <a:r>
+              <a:rPr sz="1050" b="0" i="0">
+                <a:solidFill>
+                  <a:srgbClr val="444E5C"/>
+                </a:solidFill>
+              </a:rPr>
+              <a:t>FICO 664–694 + No BC Inq + Clean DQ</a:t>
             </a:r>
           </a:p>
         </p:txBody>
@@ -12914,8 +12914,8 @@
         </p:nvSpPr>
         <p:spPr>
           <a:xfrm>
-            <a:off x="7909560" y="2578608"/>
-            <a:ext cx="1097280" cy="384048"/>
+            <a:off x="3593591" y="2560320"/>
+            <a:ext cx="1234440" cy="384048"/>
           </a:xfrm>
           <a:prstGeom prst="rect">
             <a:avLst/>
@@ -12957,28 +12957,28 @@
         </p:nvSpPr>
         <p:spPr>
           <a:xfrm>
-            <a:off x="7964424" y="2651760"/>
-            <a:ext cx="1005839" cy="292607"/>
-          </a:xfrm>
-          <a:prstGeom prst="rect">
-            <a:avLst/>
-          </a:prstGeom>
-          <a:noFill/>
-        </p:spPr>
-        <p:txBody>
-          <a:bodyPr wrap="none">
-            <a:spAutoFit/>
-          </a:bodyPr>
-          <a:lstStyle/>
-          <a:p>
-            <a:pPr algn="l"/>
-            <a:r>
-              <a:rPr sz="1100" b="1" i="0">
+            <a:off x="3639311" y="2633472"/>
+            <a:ext cx="1161288" cy="292607"/>
+          </a:xfrm>
+          <a:prstGeom prst="rect">
+            <a:avLst/>
+          </a:prstGeom>
+          <a:noFill/>
+        </p:spPr>
+        <p:txBody>
+          <a:bodyPr wrap="none">
+            <a:spAutoFit/>
+          </a:bodyPr>
+          <a:lstStyle/>
+          <a:p>
+            <a:pPr algn="l"/>
+            <a:r>
+              <a:rPr sz="1050" b="0" i="0">
                 <a:solidFill>
                   <a:srgbClr val="007B83"/>
                 </a:solidFill>
               </a:rPr>
-              <a:t>0.25%</a:t>
+              <a:t>0.28%</a:t>
             </a:r>
           </a:p>
         </p:txBody>
@@ -12991,8 +12991,8 @@
         </p:nvSpPr>
         <p:spPr>
           <a:xfrm>
-            <a:off x="9006840" y="2578608"/>
-            <a:ext cx="777240" cy="384048"/>
+            <a:off x="4828031" y="2560320"/>
+            <a:ext cx="1234440" cy="384048"/>
           </a:xfrm>
           <a:prstGeom prst="rect">
             <a:avLst/>
@@ -13034,28 +13034,28 @@
         </p:nvSpPr>
         <p:spPr>
           <a:xfrm>
-            <a:off x="9061704" y="2651760"/>
-            <a:ext cx="685800" cy="292607"/>
-          </a:xfrm>
-          <a:prstGeom prst="rect">
-            <a:avLst/>
-          </a:prstGeom>
-          <a:noFill/>
-        </p:spPr>
-        <p:txBody>
-          <a:bodyPr wrap="none">
-            <a:spAutoFit/>
-          </a:bodyPr>
-          <a:lstStyle/>
-          <a:p>
-            <a:pPr algn="l"/>
-            <a:r>
-              <a:rPr sz="1100" b="0" i="0">
-                <a:solidFill>
-                  <a:srgbClr val="CCD1D9"/>
-                </a:solidFill>
-              </a:rPr>
-              <a:t>0.41%</a:t>
+            <a:off x="4873751" y="2633472"/>
+            <a:ext cx="1161288" cy="292607"/>
+          </a:xfrm>
+          <a:prstGeom prst="rect">
+            <a:avLst/>
+          </a:prstGeom>
+          <a:noFill/>
+        </p:spPr>
+        <p:txBody>
+          <a:bodyPr wrap="none">
+            <a:spAutoFit/>
+          </a:bodyPr>
+          <a:lstStyle/>
+          <a:p>
+            <a:pPr algn="l"/>
+            <a:r>
+              <a:rPr sz="1050" b="0" i="0">
+                <a:solidFill>
+                  <a:srgbClr val="007B83"/>
+                </a:solidFill>
+              </a:rPr>
+              <a:t>0.23%</a:t>
             </a:r>
           </a:p>
         </p:txBody>
@@ -13068,14 +13068,14 @@
         </p:nvSpPr>
         <p:spPr>
           <a:xfrm>
-            <a:off x="457200" y="2990087"/>
-            <a:ext cx="274320" cy="384048"/>
-          </a:xfrm>
-          <a:prstGeom prst="rect">
-            <a:avLst/>
-          </a:prstGeom>
-          <a:solidFill>
-            <a:srgbClr val="FFFFFF"/>
+            <a:off x="6062471" y="2560320"/>
+            <a:ext cx="1234440" cy="384048"/>
+          </a:xfrm>
+          <a:prstGeom prst="rect">
+            <a:avLst/>
+          </a:prstGeom>
+          <a:solidFill>
+            <a:srgbClr val="F2F4F7"/>
           </a:solidFill>
           <a:ln>
             <a:noFill/>
@@ -13111,28 +13111,28 @@
         </p:nvSpPr>
         <p:spPr>
           <a:xfrm>
-            <a:off x="512064" y="3063239"/>
-            <a:ext cx="182879" cy="292607"/>
-          </a:xfrm>
-          <a:prstGeom prst="rect">
-            <a:avLst/>
-          </a:prstGeom>
-          <a:noFill/>
-        </p:spPr>
-        <p:txBody>
-          <a:bodyPr wrap="none">
-            <a:spAutoFit/>
-          </a:bodyPr>
-          <a:lstStyle/>
-          <a:p>
-            <a:pPr algn="l"/>
-            <a:r>
-              <a:rPr sz="1100" b="0" i="0">
-                <a:solidFill>
-                  <a:srgbClr val="444E5C"/>
-                </a:solidFill>
-              </a:rPr>
-              <a:t>4</a:t>
+            <a:off x="6108191" y="2633472"/>
+            <a:ext cx="1161288" cy="292607"/>
+          </a:xfrm>
+          <a:prstGeom prst="rect">
+            <a:avLst/>
+          </a:prstGeom>
+          <a:noFill/>
+        </p:spPr>
+        <p:txBody>
+          <a:bodyPr wrap="none">
+            <a:spAutoFit/>
+          </a:bodyPr>
+          <a:lstStyle/>
+          <a:p>
+            <a:pPr algn="l"/>
+            <a:r>
+              <a:rPr sz="1050" b="0" i="0">
+                <a:solidFill>
+                  <a:srgbClr val="007B83"/>
+                </a:solidFill>
+              </a:rPr>
+              <a:t>0.25%</a:t>
             </a:r>
           </a:p>
         </p:txBody>
@@ -13145,14 +13145,14 @@
         </p:nvSpPr>
         <p:spPr>
           <a:xfrm>
-            <a:off x="731520" y="2990087"/>
-            <a:ext cx="3200400" cy="384048"/>
-          </a:xfrm>
-          <a:prstGeom prst="rect">
-            <a:avLst/>
-          </a:prstGeom>
-          <a:solidFill>
-            <a:srgbClr val="FFFFFF"/>
+            <a:off x="7296911" y="2560320"/>
+            <a:ext cx="1005840" cy="384048"/>
+          </a:xfrm>
+          <a:prstGeom prst="rect">
+            <a:avLst/>
+          </a:prstGeom>
+          <a:solidFill>
+            <a:srgbClr val="F2F4F7"/>
           </a:solidFill>
           <a:ln>
             <a:noFill/>
@@ -13188,28 +13188,28 @@
         </p:nvSpPr>
         <p:spPr>
           <a:xfrm>
-            <a:off x="786384" y="3063239"/>
-            <a:ext cx="3108960" cy="292607"/>
-          </a:xfrm>
-          <a:prstGeom prst="rect">
-            <a:avLst/>
-          </a:prstGeom>
-          <a:noFill/>
-        </p:spPr>
-        <p:txBody>
-          <a:bodyPr wrap="none">
-            <a:spAutoFit/>
-          </a:bodyPr>
-          <a:lstStyle/>
-          <a:p>
-            <a:pPr algn="l"/>
-            <a:r>
-              <a:rPr sz="1100" b="0" i="0">
-                <a:solidFill>
-                  <a:srgbClr val="444E5C"/>
-                </a:solidFill>
-              </a:rPr>
-              <a:t>FICO 694–730 + No Inquiry + Clean DQ</a:t>
+            <a:off x="7342631" y="2633472"/>
+            <a:ext cx="932688" cy="292607"/>
+          </a:xfrm>
+          <a:prstGeom prst="rect">
+            <a:avLst/>
+          </a:prstGeom>
+          <a:noFill/>
+        </p:spPr>
+        <p:txBody>
+          <a:bodyPr wrap="none">
+            <a:spAutoFit/>
+          </a:bodyPr>
+          <a:lstStyle/>
+          <a:p>
+            <a:pPr algn="l"/>
+            <a:r>
+              <a:rPr sz="1050" b="1" i="0">
+                <a:solidFill>
+                  <a:srgbClr val="007B83"/>
+                </a:solidFill>
+              </a:rPr>
+              <a:t>0.25%</a:t>
             </a:r>
           </a:p>
         </p:txBody>
@@ -13222,14 +13222,14 @@
         </p:nvSpPr>
         <p:spPr>
           <a:xfrm>
-            <a:off x="3931920" y="2990087"/>
-            <a:ext cx="1325880" cy="384048"/>
-          </a:xfrm>
-          <a:prstGeom prst="rect">
-            <a:avLst/>
-          </a:prstGeom>
-          <a:solidFill>
-            <a:srgbClr val="FFFFFF"/>
+            <a:off x="8302751" y="2560320"/>
+            <a:ext cx="713232" cy="384048"/>
+          </a:xfrm>
+          <a:prstGeom prst="rect">
+            <a:avLst/>
+          </a:prstGeom>
+          <a:solidFill>
+            <a:srgbClr val="F2F4F7"/>
           </a:solidFill>
           <a:ln>
             <a:noFill/>
@@ -13265,28 +13265,28 @@
         </p:nvSpPr>
         <p:spPr>
           <a:xfrm>
-            <a:off x="3986783" y="3063239"/>
-            <a:ext cx="1234439" cy="292607"/>
-          </a:xfrm>
-          <a:prstGeom prst="rect">
-            <a:avLst/>
-          </a:prstGeom>
-          <a:noFill/>
-        </p:spPr>
-        <p:txBody>
-          <a:bodyPr wrap="none">
-            <a:spAutoFit/>
-          </a:bodyPr>
-          <a:lstStyle/>
-          <a:p>
-            <a:pPr algn="l"/>
-            <a:r>
-              <a:rPr sz="1100" b="0" i="0">
-                <a:solidFill>
-                  <a:srgbClr val="007B83"/>
-                </a:solidFill>
-              </a:rPr>
-              <a:t>0.30%</a:t>
+            <a:off x="8348471" y="2633472"/>
+            <a:ext cx="640080" cy="292607"/>
+          </a:xfrm>
+          <a:prstGeom prst="rect">
+            <a:avLst/>
+          </a:prstGeom>
+          <a:noFill/>
+        </p:spPr>
+        <p:txBody>
+          <a:bodyPr wrap="none">
+            <a:spAutoFit/>
+          </a:bodyPr>
+          <a:lstStyle/>
+          <a:p>
+            <a:pPr algn="l"/>
+            <a:r>
+              <a:rPr sz="1050" b="0" i="0">
+                <a:solidFill>
+                  <a:srgbClr val="CCD1D9"/>
+                </a:solidFill>
+              </a:rPr>
+              <a:t>0.41%</a:t>
             </a:r>
           </a:p>
         </p:txBody>
@@ -13299,14 +13299,14 @@
         </p:nvSpPr>
         <p:spPr>
           <a:xfrm>
-            <a:off x="5257800" y="2990087"/>
-            <a:ext cx="1325880" cy="384048"/>
-          </a:xfrm>
-          <a:prstGeom prst="rect">
-            <a:avLst/>
-          </a:prstGeom>
-          <a:solidFill>
-            <a:srgbClr val="FFFFFF"/>
+            <a:off x="9015983" y="2560320"/>
+            <a:ext cx="722376" cy="384048"/>
+          </a:xfrm>
+          <a:prstGeom prst="rect">
+            <a:avLst/>
+          </a:prstGeom>
+          <a:solidFill>
+            <a:srgbClr val="2E7D32"/>
           </a:solidFill>
           <a:ln>
             <a:noFill/>
@@ -13342,28 +13342,28 @@
         </p:nvSpPr>
         <p:spPr>
           <a:xfrm>
-            <a:off x="5312664" y="3063239"/>
-            <a:ext cx="1234439" cy="292607"/>
-          </a:xfrm>
-          <a:prstGeom prst="rect">
-            <a:avLst/>
-          </a:prstGeom>
-          <a:noFill/>
-        </p:spPr>
-        <p:txBody>
-          <a:bodyPr wrap="none">
-            <a:spAutoFit/>
-          </a:bodyPr>
-          <a:lstStyle/>
-          <a:p>
-            <a:pPr algn="l"/>
-            <a:r>
-              <a:rPr sz="1100" b="0" i="0">
-                <a:solidFill>
-                  <a:srgbClr val="007B83"/>
-                </a:solidFill>
-              </a:rPr>
-              <a:t>0.20%</a:t>
+            <a:off x="9061703" y="2633472"/>
+            <a:ext cx="649224" cy="292607"/>
+          </a:xfrm>
+          <a:prstGeom prst="rect">
+            <a:avLst/>
+          </a:prstGeom>
+          <a:noFill/>
+        </p:spPr>
+        <p:txBody>
+          <a:bodyPr wrap="none">
+            <a:spAutoFit/>
+          </a:bodyPr>
+          <a:lstStyle/>
+          <a:p>
+            <a:pPr algn="l"/>
+            <a:r>
+              <a:rPr sz="1050" b="1" i="0">
+                <a:solidFill>
+                  <a:srgbClr val="FFFFFF"/>
+                </a:solidFill>
+              </a:rPr>
+              <a:t>PASS</a:t>
             </a:r>
           </a:p>
         </p:txBody>
@@ -13376,8 +13376,8 @@
         </p:nvSpPr>
         <p:spPr>
           <a:xfrm>
-            <a:off x="6583680" y="2990087"/>
-            <a:ext cx="1325880" cy="384048"/>
+            <a:off x="320040" y="2962656"/>
+            <a:ext cx="256032" cy="384048"/>
           </a:xfrm>
           <a:prstGeom prst="rect">
             <a:avLst/>
@@ -13419,28 +13419,28 @@
         </p:nvSpPr>
         <p:spPr>
           <a:xfrm>
-            <a:off x="6638544" y="3063239"/>
-            <a:ext cx="1234439" cy="292607"/>
-          </a:xfrm>
-          <a:prstGeom prst="rect">
-            <a:avLst/>
-          </a:prstGeom>
-          <a:noFill/>
-        </p:spPr>
-        <p:txBody>
-          <a:bodyPr wrap="none">
-            <a:spAutoFit/>
-          </a:bodyPr>
-          <a:lstStyle/>
-          <a:p>
-            <a:pPr algn="l"/>
-            <a:r>
-              <a:rPr sz="1100" b="0" i="0">
-                <a:solidFill>
-                  <a:srgbClr val="007B83"/>
-                </a:solidFill>
-              </a:rPr>
-              <a:t>0.28%</a:t>
+            <a:off x="365759" y="3035808"/>
+            <a:ext cx="182880" cy="292607"/>
+          </a:xfrm>
+          <a:prstGeom prst="rect">
+            <a:avLst/>
+          </a:prstGeom>
+          <a:noFill/>
+        </p:spPr>
+        <p:txBody>
+          <a:bodyPr wrap="none">
+            <a:spAutoFit/>
+          </a:bodyPr>
+          <a:lstStyle/>
+          <a:p>
+            <a:pPr algn="l"/>
+            <a:r>
+              <a:rPr sz="1050" b="0" i="0">
+                <a:solidFill>
+                  <a:srgbClr val="444E5C"/>
+                </a:solidFill>
+              </a:rPr>
+              <a:t>4</a:t>
             </a:r>
           </a:p>
         </p:txBody>
@@ -13453,8 +13453,8 @@
         </p:nvSpPr>
         <p:spPr>
           <a:xfrm>
-            <a:off x="7909560" y="2990087"/>
-            <a:ext cx="1097280" cy="384048"/>
+            <a:off x="576072" y="2962656"/>
+            <a:ext cx="3017520" cy="384048"/>
           </a:xfrm>
           <a:prstGeom prst="rect">
             <a:avLst/>
@@ -13496,28 +13496,28 @@
         </p:nvSpPr>
         <p:spPr>
           <a:xfrm>
-            <a:off x="7964424" y="3063239"/>
-            <a:ext cx="1005839" cy="292607"/>
-          </a:xfrm>
-          <a:prstGeom prst="rect">
-            <a:avLst/>
-          </a:prstGeom>
-          <a:noFill/>
-        </p:spPr>
-        <p:txBody>
-          <a:bodyPr wrap="none">
-            <a:spAutoFit/>
-          </a:bodyPr>
-          <a:lstStyle/>
-          <a:p>
-            <a:pPr algn="l"/>
-            <a:r>
-              <a:rPr sz="1100" b="1" i="0">
-                <a:solidFill>
-                  <a:srgbClr val="007B83"/>
-                </a:solidFill>
-              </a:rPr>
-              <a:t>0.26%</a:t>
+            <a:off x="621792" y="3035808"/>
+            <a:ext cx="2944368" cy="292607"/>
+          </a:xfrm>
+          <a:prstGeom prst="rect">
+            <a:avLst/>
+          </a:prstGeom>
+          <a:noFill/>
+        </p:spPr>
+        <p:txBody>
+          <a:bodyPr wrap="none">
+            <a:spAutoFit/>
+          </a:bodyPr>
+          <a:lstStyle/>
+          <a:p>
+            <a:pPr algn="l"/>
+            <a:r>
+              <a:rPr sz="1050" b="0" i="0">
+                <a:solidFill>
+                  <a:srgbClr val="444E5C"/>
+                </a:solidFill>
+              </a:rPr>
+              <a:t>FICO 694–730 + No Inquiry + Clean DQ</a:t>
             </a:r>
           </a:p>
         </p:txBody>
@@ -13530,8 +13530,8 @@
         </p:nvSpPr>
         <p:spPr>
           <a:xfrm>
-            <a:off x="9006840" y="2990087"/>
-            <a:ext cx="777240" cy="384048"/>
+            <a:off x="3593591" y="2962656"/>
+            <a:ext cx="1234440" cy="384048"/>
           </a:xfrm>
           <a:prstGeom prst="rect">
             <a:avLst/>
@@ -13573,28 +13573,28 @@
         </p:nvSpPr>
         <p:spPr>
           <a:xfrm>
-            <a:off x="9061704" y="3063239"/>
-            <a:ext cx="685800" cy="292607"/>
-          </a:xfrm>
-          <a:prstGeom prst="rect">
-            <a:avLst/>
-          </a:prstGeom>
-          <a:noFill/>
-        </p:spPr>
-        <p:txBody>
-          <a:bodyPr wrap="none">
-            <a:spAutoFit/>
-          </a:bodyPr>
-          <a:lstStyle/>
-          <a:p>
-            <a:pPr algn="l"/>
-            <a:r>
-              <a:rPr sz="1100" b="0" i="0">
-                <a:solidFill>
-                  <a:srgbClr val="CCD1D9"/>
-                </a:solidFill>
-              </a:rPr>
-              <a:t>0.41%</a:t>
+            <a:off x="3639311" y="3035808"/>
+            <a:ext cx="1161288" cy="292607"/>
+          </a:xfrm>
+          <a:prstGeom prst="rect">
+            <a:avLst/>
+          </a:prstGeom>
+          <a:noFill/>
+        </p:spPr>
+        <p:txBody>
+          <a:bodyPr wrap="none">
+            <a:spAutoFit/>
+          </a:bodyPr>
+          <a:lstStyle/>
+          <a:p>
+            <a:pPr algn="l"/>
+            <a:r>
+              <a:rPr sz="1050" b="0" i="0">
+                <a:solidFill>
+                  <a:srgbClr val="007B83"/>
+                </a:solidFill>
+              </a:rPr>
+              <a:t>0.30%</a:t>
             </a:r>
           </a:p>
         </p:txBody>
@@ -13607,14 +13607,14 @@
         </p:nvSpPr>
         <p:spPr>
           <a:xfrm>
-            <a:off x="457200" y="3401568"/>
-            <a:ext cx="274320" cy="384048"/>
-          </a:xfrm>
-          <a:prstGeom prst="rect">
-            <a:avLst/>
-          </a:prstGeom>
-          <a:solidFill>
-            <a:srgbClr val="F2F4F7"/>
+            <a:off x="4828031" y="2962656"/>
+            <a:ext cx="1234440" cy="384048"/>
+          </a:xfrm>
+          <a:prstGeom prst="rect">
+            <a:avLst/>
+          </a:prstGeom>
+          <a:solidFill>
+            <a:srgbClr val="FFFFFF"/>
           </a:solidFill>
           <a:ln>
             <a:noFill/>
@@ -13650,28 +13650,28 @@
         </p:nvSpPr>
         <p:spPr>
           <a:xfrm>
-            <a:off x="512064" y="3474720"/>
-            <a:ext cx="182879" cy="292607"/>
-          </a:xfrm>
-          <a:prstGeom prst="rect">
-            <a:avLst/>
-          </a:prstGeom>
-          <a:noFill/>
-        </p:spPr>
-        <p:txBody>
-          <a:bodyPr wrap="none">
-            <a:spAutoFit/>
-          </a:bodyPr>
-          <a:lstStyle/>
-          <a:p>
-            <a:pPr algn="l"/>
-            <a:r>
-              <a:rPr sz="1100" b="0" i="0">
-                <a:solidFill>
-                  <a:srgbClr val="444E5C"/>
-                </a:solidFill>
-              </a:rPr>
-              <a:t>5</a:t>
+            <a:off x="4873751" y="3035808"/>
+            <a:ext cx="1161288" cy="292607"/>
+          </a:xfrm>
+          <a:prstGeom prst="rect">
+            <a:avLst/>
+          </a:prstGeom>
+          <a:noFill/>
+        </p:spPr>
+        <p:txBody>
+          <a:bodyPr wrap="none">
+            <a:spAutoFit/>
+          </a:bodyPr>
+          <a:lstStyle/>
+          <a:p>
+            <a:pPr algn="l"/>
+            <a:r>
+              <a:rPr sz="1050" b="0" i="0">
+                <a:solidFill>
+                  <a:srgbClr val="007B83"/>
+                </a:solidFill>
+              </a:rPr>
+              <a:t>0.20%</a:t>
             </a:r>
           </a:p>
         </p:txBody>
@@ -13684,14 +13684,14 @@
         </p:nvSpPr>
         <p:spPr>
           <a:xfrm>
-            <a:off x="731520" y="3401568"/>
-            <a:ext cx="3200400" cy="384048"/>
-          </a:xfrm>
-          <a:prstGeom prst="rect">
-            <a:avLst/>
-          </a:prstGeom>
-          <a:solidFill>
-            <a:srgbClr val="F2F4F7"/>
+            <a:off x="6062471" y="2962656"/>
+            <a:ext cx="1234440" cy="384048"/>
+          </a:xfrm>
+          <a:prstGeom prst="rect">
+            <a:avLst/>
+          </a:prstGeom>
+          <a:solidFill>
+            <a:srgbClr val="FFFFFF"/>
           </a:solidFill>
           <a:ln>
             <a:noFill/>
@@ -13727,28 +13727,28 @@
         </p:nvSpPr>
         <p:spPr>
           <a:xfrm>
-            <a:off x="786384" y="3474720"/>
-            <a:ext cx="3108960" cy="292607"/>
-          </a:xfrm>
-          <a:prstGeom prst="rect">
-            <a:avLst/>
-          </a:prstGeom>
-          <a:noFill/>
-        </p:spPr>
-        <p:txBody>
-          <a:bodyPr wrap="none">
-            <a:spAutoFit/>
-          </a:bodyPr>
-          <a:lstStyle/>
-          <a:p>
-            <a:pPr algn="l"/>
-            <a:r>
-              <a:rPr sz="1100" b="0" i="0">
-                <a:solidFill>
-                  <a:srgbClr val="444E5C"/>
-                </a:solidFill>
-              </a:rPr>
-              <a:t>FICO 664–694 + Clean BC DQ 3mo</a:t>
+            <a:off x="6108191" y="3035808"/>
+            <a:ext cx="1161288" cy="292607"/>
+          </a:xfrm>
+          <a:prstGeom prst="rect">
+            <a:avLst/>
+          </a:prstGeom>
+          <a:noFill/>
+        </p:spPr>
+        <p:txBody>
+          <a:bodyPr wrap="none">
+            <a:spAutoFit/>
+          </a:bodyPr>
+          <a:lstStyle/>
+          <a:p>
+            <a:pPr algn="l"/>
+            <a:r>
+              <a:rPr sz="1050" b="0" i="0">
+                <a:solidFill>
+                  <a:srgbClr val="007B83"/>
+                </a:solidFill>
+              </a:rPr>
+              <a:t>0.28%</a:t>
             </a:r>
           </a:p>
         </p:txBody>
@@ -13761,14 +13761,14 @@
         </p:nvSpPr>
         <p:spPr>
           <a:xfrm>
-            <a:off x="3931920" y="3401568"/>
-            <a:ext cx="1325880" cy="384048"/>
-          </a:xfrm>
-          <a:prstGeom prst="rect">
-            <a:avLst/>
-          </a:prstGeom>
-          <a:solidFill>
-            <a:srgbClr val="F2F4F7"/>
+            <a:off x="7296911" y="2962656"/>
+            <a:ext cx="1005840" cy="384048"/>
+          </a:xfrm>
+          <a:prstGeom prst="rect">
+            <a:avLst/>
+          </a:prstGeom>
+          <a:solidFill>
+            <a:srgbClr val="FFFFFF"/>
           </a:solidFill>
           <a:ln>
             <a:noFill/>
@@ -13804,23 +13804,23 @@
         </p:nvSpPr>
         <p:spPr>
           <a:xfrm>
-            <a:off x="3986783" y="3474720"/>
-            <a:ext cx="1234439" cy="292607"/>
-          </a:xfrm>
-          <a:prstGeom prst="rect">
-            <a:avLst/>
-          </a:prstGeom>
-          <a:noFill/>
-        </p:spPr>
-        <p:txBody>
-          <a:bodyPr wrap="none">
-            <a:spAutoFit/>
-          </a:bodyPr>
-          <a:lstStyle/>
-          <a:p>
-            <a:pPr algn="l"/>
-            <a:r>
-              <a:rPr sz="1100" b="0" i="0">
+            <a:off x="7342631" y="3035808"/>
+            <a:ext cx="932688" cy="292607"/>
+          </a:xfrm>
+          <a:prstGeom prst="rect">
+            <a:avLst/>
+          </a:prstGeom>
+          <a:noFill/>
+        </p:spPr>
+        <p:txBody>
+          <a:bodyPr wrap="none">
+            <a:spAutoFit/>
+          </a:bodyPr>
+          <a:lstStyle/>
+          <a:p>
+            <a:pPr algn="l"/>
+            <a:r>
+              <a:rPr sz="1050" b="1" i="0">
                 <a:solidFill>
                   <a:srgbClr val="007B83"/>
                 </a:solidFill>
@@ -13838,14 +13838,14 @@
         </p:nvSpPr>
         <p:spPr>
           <a:xfrm>
-            <a:off x="5257800" y="3401568"/>
-            <a:ext cx="1325880" cy="384048"/>
-          </a:xfrm>
-          <a:prstGeom prst="rect">
-            <a:avLst/>
-          </a:prstGeom>
-          <a:solidFill>
-            <a:srgbClr val="F2F4F7"/>
+            <a:off x="8302751" y="2962656"/>
+            <a:ext cx="713232" cy="384048"/>
+          </a:xfrm>
+          <a:prstGeom prst="rect">
+            <a:avLst/>
+          </a:prstGeom>
+          <a:solidFill>
+            <a:srgbClr val="FFFFFF"/>
           </a:solidFill>
           <a:ln>
             <a:noFill/>
@@ -13881,28 +13881,28 @@
         </p:nvSpPr>
         <p:spPr>
           <a:xfrm>
-            <a:off x="5312664" y="3474720"/>
-            <a:ext cx="1234439" cy="292607"/>
-          </a:xfrm>
-          <a:prstGeom prst="rect">
-            <a:avLst/>
-          </a:prstGeom>
-          <a:noFill/>
-        </p:spPr>
-        <p:txBody>
-          <a:bodyPr wrap="none">
-            <a:spAutoFit/>
-          </a:bodyPr>
-          <a:lstStyle/>
-          <a:p>
-            <a:pPr algn="l"/>
-            <a:r>
-              <a:rPr sz="1100" b="0" i="0">
-                <a:solidFill>
-                  <a:srgbClr val="007B83"/>
-                </a:solidFill>
-              </a:rPr>
-              <a:t>0.23%</a:t>
+            <a:off x="8348471" y="3035808"/>
+            <a:ext cx="640080" cy="292607"/>
+          </a:xfrm>
+          <a:prstGeom prst="rect">
+            <a:avLst/>
+          </a:prstGeom>
+          <a:noFill/>
+        </p:spPr>
+        <p:txBody>
+          <a:bodyPr wrap="none">
+            <a:spAutoFit/>
+          </a:bodyPr>
+          <a:lstStyle/>
+          <a:p>
+            <a:pPr algn="l"/>
+            <a:r>
+              <a:rPr sz="1050" b="0" i="0">
+                <a:solidFill>
+                  <a:srgbClr val="CCD1D9"/>
+                </a:solidFill>
+              </a:rPr>
+              <a:t>0.41%</a:t>
             </a:r>
           </a:p>
         </p:txBody>
@@ -13915,14 +13915,14 @@
         </p:nvSpPr>
         <p:spPr>
           <a:xfrm>
-            <a:off x="6583680" y="3401568"/>
-            <a:ext cx="1325880" cy="384048"/>
-          </a:xfrm>
-          <a:prstGeom prst="rect">
-            <a:avLst/>
-          </a:prstGeom>
-          <a:solidFill>
-            <a:srgbClr val="F2F4F7"/>
+            <a:off x="9015983" y="2962656"/>
+            <a:ext cx="722376" cy="384048"/>
+          </a:xfrm>
+          <a:prstGeom prst="rect">
+            <a:avLst/>
+          </a:prstGeom>
+          <a:solidFill>
+            <a:srgbClr val="2E7D32"/>
           </a:solidFill>
           <a:ln>
             <a:noFill/>
@@ -13958,28 +13958,28 @@
         </p:nvSpPr>
         <p:spPr>
           <a:xfrm>
-            <a:off x="6638544" y="3474720"/>
-            <a:ext cx="1234439" cy="292607"/>
-          </a:xfrm>
-          <a:prstGeom prst="rect">
-            <a:avLst/>
-          </a:prstGeom>
-          <a:noFill/>
-        </p:spPr>
-        <p:txBody>
-          <a:bodyPr wrap="none">
-            <a:spAutoFit/>
-          </a:bodyPr>
-          <a:lstStyle/>
-          <a:p>
-            <a:pPr algn="l"/>
-            <a:r>
-              <a:rPr sz="1100" b="0" i="0">
-                <a:solidFill>
-                  <a:srgbClr val="007B83"/>
-                </a:solidFill>
-              </a:rPr>
-              <a:t>0.30%</a:t>
+            <a:off x="9061703" y="3035808"/>
+            <a:ext cx="649224" cy="292607"/>
+          </a:xfrm>
+          <a:prstGeom prst="rect">
+            <a:avLst/>
+          </a:prstGeom>
+          <a:noFill/>
+        </p:spPr>
+        <p:txBody>
+          <a:bodyPr wrap="none">
+            <a:spAutoFit/>
+          </a:bodyPr>
+          <a:lstStyle/>
+          <a:p>
+            <a:pPr algn="l"/>
+            <a:r>
+              <a:rPr sz="1050" b="1" i="0">
+                <a:solidFill>
+                  <a:srgbClr val="FFFFFF"/>
+                </a:solidFill>
+              </a:rPr>
+              <a:t>PASS</a:t>
             </a:r>
           </a:p>
         </p:txBody>
@@ -13992,8 +13992,8 @@
         </p:nvSpPr>
         <p:spPr>
           <a:xfrm>
-            <a:off x="7909560" y="3401568"/>
-            <a:ext cx="1097280" cy="384048"/>
+            <a:off x="320040" y="3364991"/>
+            <a:ext cx="256032" cy="384048"/>
           </a:xfrm>
           <a:prstGeom prst="rect">
             <a:avLst/>
@@ -14035,28 +14035,28 @@
         </p:nvSpPr>
         <p:spPr>
           <a:xfrm>
-            <a:off x="7964424" y="3474720"/>
-            <a:ext cx="1005839" cy="292607"/>
-          </a:xfrm>
-          <a:prstGeom prst="rect">
-            <a:avLst/>
-          </a:prstGeom>
-          <a:noFill/>
-        </p:spPr>
-        <p:txBody>
-          <a:bodyPr wrap="none">
-            <a:spAutoFit/>
-          </a:bodyPr>
-          <a:lstStyle/>
-          <a:p>
-            <a:pPr algn="l"/>
-            <a:r>
-              <a:rPr sz="1100" b="1" i="0">
-                <a:solidFill>
-                  <a:srgbClr val="007B83"/>
-                </a:solidFill>
-              </a:rPr>
-              <a:t>0.26%</a:t>
+            <a:off x="365759" y="3438144"/>
+            <a:ext cx="182880" cy="292607"/>
+          </a:xfrm>
+          <a:prstGeom prst="rect">
+            <a:avLst/>
+          </a:prstGeom>
+          <a:noFill/>
+        </p:spPr>
+        <p:txBody>
+          <a:bodyPr wrap="none">
+            <a:spAutoFit/>
+          </a:bodyPr>
+          <a:lstStyle/>
+          <a:p>
+            <a:pPr algn="l"/>
+            <a:r>
+              <a:rPr sz="1050" b="0" i="0">
+                <a:solidFill>
+                  <a:srgbClr val="444E5C"/>
+                </a:solidFill>
+              </a:rPr>
+              <a:t>5</a:t>
             </a:r>
           </a:p>
         </p:txBody>
@@ -14069,8 +14069,8 @@
         </p:nvSpPr>
         <p:spPr>
           <a:xfrm>
-            <a:off x="9006840" y="3401568"/>
-            <a:ext cx="777240" cy="384048"/>
+            <a:off x="576072" y="3364991"/>
+            <a:ext cx="3017520" cy="384048"/>
           </a:xfrm>
           <a:prstGeom prst="rect">
             <a:avLst/>
@@ -14112,28 +14112,28 @@
         </p:nvSpPr>
         <p:spPr>
           <a:xfrm>
-            <a:off x="9061704" y="3474720"/>
-            <a:ext cx="685800" cy="292607"/>
-          </a:xfrm>
-          <a:prstGeom prst="rect">
-            <a:avLst/>
-          </a:prstGeom>
-          <a:noFill/>
-        </p:spPr>
-        <p:txBody>
-          <a:bodyPr wrap="none">
-            <a:spAutoFit/>
-          </a:bodyPr>
-          <a:lstStyle/>
-          <a:p>
-            <a:pPr algn="l"/>
-            <a:r>
-              <a:rPr sz="1100" b="0" i="0">
-                <a:solidFill>
-                  <a:srgbClr val="CCD1D9"/>
-                </a:solidFill>
-              </a:rPr>
-              <a:t>0.41%</a:t>
+            <a:off x="621792" y="3438144"/>
+            <a:ext cx="2944368" cy="292607"/>
+          </a:xfrm>
+          <a:prstGeom prst="rect">
+            <a:avLst/>
+          </a:prstGeom>
+          <a:noFill/>
+        </p:spPr>
+        <p:txBody>
+          <a:bodyPr wrap="none">
+            <a:spAutoFit/>
+          </a:bodyPr>
+          <a:lstStyle/>
+          <a:p>
+            <a:pPr algn="l"/>
+            <a:r>
+              <a:rPr sz="1050" b="0" i="0">
+                <a:solidFill>
+                  <a:srgbClr val="444E5C"/>
+                </a:solidFill>
+              </a:rPr>
+              <a:t>FICO 664–694 + Clean BC DQ 3mo</a:t>
             </a:r>
           </a:p>
         </p:txBody>
@@ -14146,14 +14146,14 @@
         </p:nvSpPr>
         <p:spPr>
           <a:xfrm>
-            <a:off x="457200" y="4480560"/>
-            <a:ext cx="11247120" cy="457200"/>
-          </a:xfrm>
-          <a:prstGeom prst="rect">
-            <a:avLst/>
-          </a:prstGeom>
-          <a:solidFill>
-            <a:srgbClr val="FFF3E0"/>
+            <a:off x="3593591" y="3364991"/>
+            <a:ext cx="1234440" cy="384048"/>
+          </a:xfrm>
+          <a:prstGeom prst="rect">
+            <a:avLst/>
+          </a:prstGeom>
+          <a:solidFill>
+            <a:srgbClr val="F2F4F7"/>
           </a:solidFill>
           <a:ln>
             <a:noFill/>
@@ -14189,62 +14189,1106 @@
         </p:nvSpPr>
         <p:spPr>
           <a:xfrm>
-            <a:off x="594360" y="4526280"/>
-            <a:ext cx="10972800" cy="320040"/>
-          </a:xfrm>
-          <a:prstGeom prst="rect">
-            <a:avLst/>
-          </a:prstGeom>
-          <a:noFill/>
-        </p:spPr>
-        <p:txBody>
-          <a:bodyPr wrap="none">
-            <a:spAutoFit/>
-          </a:bodyPr>
-          <a:lstStyle/>
-          <a:p>
-            <a:pPr algn="l"/>
-            <a:r>
-              <a:rPr sz="1100" b="0" i="0">
-                <a:solidFill>
-                  <a:srgbClr val="C41E3A"/>
-                </a:solidFill>
-              </a:rPr>
-              <a:t>BAU = 0.41%  |  Every cell above is BELOW BAU — confirming persistent non-response across all mailing waves.</a:t>
-            </a:r>
-          </a:p>
-        </p:txBody>
-      </p:sp>
-      <p:sp>
-        <p:nvSpPr>
-          <p:cNvPr id="94" name="TextBox 93"/>
-          <p:cNvSpPr txBox="1"/>
-          <p:nvPr/>
-        </p:nvSpPr>
-        <p:spPr>
-          <a:xfrm>
-            <a:off x="457200" y="5074920"/>
-            <a:ext cx="11548872" cy="411480"/>
-          </a:xfrm>
-          <a:prstGeom prst="rect">
-            <a:avLst/>
-          </a:prstGeom>
-          <a:noFill/>
-        </p:spPr>
-        <p:txBody>
-          <a:bodyPr wrap="none">
-            <a:spAutoFit/>
-          </a:bodyPr>
-          <a:lstStyle/>
-          <a:p>
-            <a:pPr algn="l"/>
-            <a:r>
-              <a:rPr sz="900" b="0" i="1">
+            <a:off x="3639311" y="3438144"/>
+            <a:ext cx="1161288" cy="292607"/>
+          </a:xfrm>
+          <a:prstGeom prst="rect">
+            <a:avLst/>
+          </a:prstGeom>
+          <a:noFill/>
+        </p:spPr>
+        <p:txBody>
+          <a:bodyPr wrap="none">
+            <a:spAutoFit/>
+          </a:bodyPr>
+          <a:lstStyle/>
+          <a:p>
+            <a:pPr algn="l"/>
+            <a:r>
+              <a:rPr sz="1050" b="0" i="0">
+                <a:solidFill>
+                  <a:srgbClr val="007B83"/>
+                </a:solidFill>
+              </a:rPr>
+              <a:t>0.26%</a:t>
+            </a:r>
+          </a:p>
+        </p:txBody>
+      </p:sp>
+      <p:sp>
+        <p:nvSpPr>
+          <p:cNvPr id="94" name="Rectangle 93"/>
+          <p:cNvSpPr/>
+          <p:nvPr/>
+        </p:nvSpPr>
+        <p:spPr>
+          <a:xfrm>
+            <a:off x="4828031" y="3364991"/>
+            <a:ext cx="1234440" cy="384048"/>
+          </a:xfrm>
+          <a:prstGeom prst="rect">
+            <a:avLst/>
+          </a:prstGeom>
+          <a:solidFill>
+            <a:srgbClr val="F2F4F7"/>
+          </a:solidFill>
+          <a:ln>
+            <a:noFill/>
+          </a:ln>
+        </p:spPr>
+        <p:style>
+          <a:lnRef idx="1">
+            <a:schemeClr val="accent1"/>
+          </a:lnRef>
+          <a:fillRef idx="3">
+            <a:schemeClr val="accent1"/>
+          </a:fillRef>
+          <a:effectRef idx="2">
+            <a:schemeClr val="accent1"/>
+          </a:effectRef>
+          <a:fontRef idx="minor">
+            <a:schemeClr val="lt1"/>
+          </a:fontRef>
+        </p:style>
+        <p:txBody>
+          <a:bodyPr rtlCol="0" anchor="ctr"/>
+          <a:lstStyle/>
+          <a:p>
+            <a:pPr algn="ctr"/>
+          </a:p>
+        </p:txBody>
+      </p:sp>
+      <p:sp>
+        <p:nvSpPr>
+          <p:cNvPr id="95" name="TextBox 94"/>
+          <p:cNvSpPr txBox="1"/>
+          <p:nvPr/>
+        </p:nvSpPr>
+        <p:spPr>
+          <a:xfrm>
+            <a:off x="4873751" y="3438144"/>
+            <a:ext cx="1161288" cy="292607"/>
+          </a:xfrm>
+          <a:prstGeom prst="rect">
+            <a:avLst/>
+          </a:prstGeom>
+          <a:noFill/>
+        </p:spPr>
+        <p:txBody>
+          <a:bodyPr wrap="none">
+            <a:spAutoFit/>
+          </a:bodyPr>
+          <a:lstStyle/>
+          <a:p>
+            <a:pPr algn="l"/>
+            <a:r>
+              <a:rPr sz="1050" b="0" i="0">
+                <a:solidFill>
+                  <a:srgbClr val="007B83"/>
+                </a:solidFill>
+              </a:rPr>
+              <a:t>0.23%</a:t>
+            </a:r>
+          </a:p>
+        </p:txBody>
+      </p:sp>
+      <p:sp>
+        <p:nvSpPr>
+          <p:cNvPr id="96" name="Rectangle 95"/>
+          <p:cNvSpPr/>
+          <p:nvPr/>
+        </p:nvSpPr>
+        <p:spPr>
+          <a:xfrm>
+            <a:off x="6062471" y="3364991"/>
+            <a:ext cx="1234440" cy="384048"/>
+          </a:xfrm>
+          <a:prstGeom prst="rect">
+            <a:avLst/>
+          </a:prstGeom>
+          <a:solidFill>
+            <a:srgbClr val="F2F4F7"/>
+          </a:solidFill>
+          <a:ln>
+            <a:noFill/>
+          </a:ln>
+        </p:spPr>
+        <p:style>
+          <a:lnRef idx="1">
+            <a:schemeClr val="accent1"/>
+          </a:lnRef>
+          <a:fillRef idx="3">
+            <a:schemeClr val="accent1"/>
+          </a:fillRef>
+          <a:effectRef idx="2">
+            <a:schemeClr val="accent1"/>
+          </a:effectRef>
+          <a:fontRef idx="minor">
+            <a:schemeClr val="lt1"/>
+          </a:fontRef>
+        </p:style>
+        <p:txBody>
+          <a:bodyPr rtlCol="0" anchor="ctr"/>
+          <a:lstStyle/>
+          <a:p>
+            <a:pPr algn="ctr"/>
+          </a:p>
+        </p:txBody>
+      </p:sp>
+      <p:sp>
+        <p:nvSpPr>
+          <p:cNvPr id="97" name="TextBox 96"/>
+          <p:cNvSpPr txBox="1"/>
+          <p:nvPr/>
+        </p:nvSpPr>
+        <p:spPr>
+          <a:xfrm>
+            <a:off x="6108191" y="3438144"/>
+            <a:ext cx="1161288" cy="292607"/>
+          </a:xfrm>
+          <a:prstGeom prst="rect">
+            <a:avLst/>
+          </a:prstGeom>
+          <a:noFill/>
+        </p:spPr>
+        <p:txBody>
+          <a:bodyPr wrap="none">
+            <a:spAutoFit/>
+          </a:bodyPr>
+          <a:lstStyle/>
+          <a:p>
+            <a:pPr algn="l"/>
+            <a:r>
+              <a:rPr sz="1050" b="0" i="0">
+                <a:solidFill>
+                  <a:srgbClr val="007B83"/>
+                </a:solidFill>
+              </a:rPr>
+              <a:t>0.30%</a:t>
+            </a:r>
+          </a:p>
+        </p:txBody>
+      </p:sp>
+      <p:sp>
+        <p:nvSpPr>
+          <p:cNvPr id="98" name="Rectangle 97"/>
+          <p:cNvSpPr/>
+          <p:nvPr/>
+        </p:nvSpPr>
+        <p:spPr>
+          <a:xfrm>
+            <a:off x="7296911" y="3364991"/>
+            <a:ext cx="1005840" cy="384048"/>
+          </a:xfrm>
+          <a:prstGeom prst="rect">
+            <a:avLst/>
+          </a:prstGeom>
+          <a:solidFill>
+            <a:srgbClr val="F2F4F7"/>
+          </a:solidFill>
+          <a:ln>
+            <a:noFill/>
+          </a:ln>
+        </p:spPr>
+        <p:style>
+          <a:lnRef idx="1">
+            <a:schemeClr val="accent1"/>
+          </a:lnRef>
+          <a:fillRef idx="3">
+            <a:schemeClr val="accent1"/>
+          </a:fillRef>
+          <a:effectRef idx="2">
+            <a:schemeClr val="accent1"/>
+          </a:effectRef>
+          <a:fontRef idx="minor">
+            <a:schemeClr val="lt1"/>
+          </a:fontRef>
+        </p:style>
+        <p:txBody>
+          <a:bodyPr rtlCol="0" anchor="ctr"/>
+          <a:lstStyle/>
+          <a:p>
+            <a:pPr algn="ctr"/>
+          </a:p>
+        </p:txBody>
+      </p:sp>
+      <p:sp>
+        <p:nvSpPr>
+          <p:cNvPr id="99" name="TextBox 98"/>
+          <p:cNvSpPr txBox="1"/>
+          <p:nvPr/>
+        </p:nvSpPr>
+        <p:spPr>
+          <a:xfrm>
+            <a:off x="7342631" y="3438144"/>
+            <a:ext cx="932688" cy="292607"/>
+          </a:xfrm>
+          <a:prstGeom prst="rect">
+            <a:avLst/>
+          </a:prstGeom>
+          <a:noFill/>
+        </p:spPr>
+        <p:txBody>
+          <a:bodyPr wrap="none">
+            <a:spAutoFit/>
+          </a:bodyPr>
+          <a:lstStyle/>
+          <a:p>
+            <a:pPr algn="l"/>
+            <a:r>
+              <a:rPr sz="1050" b="1" i="0">
+                <a:solidFill>
+                  <a:srgbClr val="007B83"/>
+                </a:solidFill>
+              </a:rPr>
+              <a:t>0.26%</a:t>
+            </a:r>
+          </a:p>
+        </p:txBody>
+      </p:sp>
+      <p:sp>
+        <p:nvSpPr>
+          <p:cNvPr id="100" name="Rectangle 99"/>
+          <p:cNvSpPr/>
+          <p:nvPr/>
+        </p:nvSpPr>
+        <p:spPr>
+          <a:xfrm>
+            <a:off x="8302751" y="3364991"/>
+            <a:ext cx="713232" cy="384048"/>
+          </a:xfrm>
+          <a:prstGeom prst="rect">
+            <a:avLst/>
+          </a:prstGeom>
+          <a:solidFill>
+            <a:srgbClr val="F2F4F7"/>
+          </a:solidFill>
+          <a:ln>
+            <a:noFill/>
+          </a:ln>
+        </p:spPr>
+        <p:style>
+          <a:lnRef idx="1">
+            <a:schemeClr val="accent1"/>
+          </a:lnRef>
+          <a:fillRef idx="3">
+            <a:schemeClr val="accent1"/>
+          </a:fillRef>
+          <a:effectRef idx="2">
+            <a:schemeClr val="accent1"/>
+          </a:effectRef>
+          <a:fontRef idx="minor">
+            <a:schemeClr val="lt1"/>
+          </a:fontRef>
+        </p:style>
+        <p:txBody>
+          <a:bodyPr rtlCol="0" anchor="ctr"/>
+          <a:lstStyle/>
+          <a:p>
+            <a:pPr algn="ctr"/>
+          </a:p>
+        </p:txBody>
+      </p:sp>
+      <p:sp>
+        <p:nvSpPr>
+          <p:cNvPr id="101" name="TextBox 100"/>
+          <p:cNvSpPr txBox="1"/>
+          <p:nvPr/>
+        </p:nvSpPr>
+        <p:spPr>
+          <a:xfrm>
+            <a:off x="8348471" y="3438144"/>
+            <a:ext cx="640080" cy="292607"/>
+          </a:xfrm>
+          <a:prstGeom prst="rect">
+            <a:avLst/>
+          </a:prstGeom>
+          <a:noFill/>
+        </p:spPr>
+        <p:txBody>
+          <a:bodyPr wrap="none">
+            <a:spAutoFit/>
+          </a:bodyPr>
+          <a:lstStyle/>
+          <a:p>
+            <a:pPr algn="l"/>
+            <a:r>
+              <a:rPr sz="1050" b="0" i="0">
                 <a:solidFill>
                   <a:srgbClr val="CCD1D9"/>
                 </a:solidFill>
               </a:rPr>
-              <a:t>Stability note: formal stable=True requires all waves &lt; 0.205% (50% of BAU). No rule clears that strict bar, but all are consistently below BAU in every wave — operationally valid for suppression.</a:t>
+              <a:t>0.41%</a:t>
+            </a:r>
+          </a:p>
+        </p:txBody>
+      </p:sp>
+      <p:sp>
+        <p:nvSpPr>
+          <p:cNvPr id="102" name="Rectangle 101"/>
+          <p:cNvSpPr/>
+          <p:nvPr/>
+        </p:nvSpPr>
+        <p:spPr>
+          <a:xfrm>
+            <a:off x="9015983" y="3364991"/>
+            <a:ext cx="722376" cy="384048"/>
+          </a:xfrm>
+          <a:prstGeom prst="rect">
+            <a:avLst/>
+          </a:prstGeom>
+          <a:solidFill>
+            <a:srgbClr val="2E7D32"/>
+          </a:solidFill>
+          <a:ln>
+            <a:noFill/>
+          </a:ln>
+        </p:spPr>
+        <p:style>
+          <a:lnRef idx="1">
+            <a:schemeClr val="accent1"/>
+          </a:lnRef>
+          <a:fillRef idx="3">
+            <a:schemeClr val="accent1"/>
+          </a:fillRef>
+          <a:effectRef idx="2">
+            <a:schemeClr val="accent1"/>
+          </a:effectRef>
+          <a:fontRef idx="minor">
+            <a:schemeClr val="lt1"/>
+          </a:fontRef>
+        </p:style>
+        <p:txBody>
+          <a:bodyPr rtlCol="0" anchor="ctr"/>
+          <a:lstStyle/>
+          <a:p>
+            <a:pPr algn="ctr"/>
+          </a:p>
+        </p:txBody>
+      </p:sp>
+      <p:sp>
+        <p:nvSpPr>
+          <p:cNvPr id="103" name="TextBox 102"/>
+          <p:cNvSpPr txBox="1"/>
+          <p:nvPr/>
+        </p:nvSpPr>
+        <p:spPr>
+          <a:xfrm>
+            <a:off x="9061703" y="3438144"/>
+            <a:ext cx="649224" cy="292607"/>
+          </a:xfrm>
+          <a:prstGeom prst="rect">
+            <a:avLst/>
+          </a:prstGeom>
+          <a:noFill/>
+        </p:spPr>
+        <p:txBody>
+          <a:bodyPr wrap="none">
+            <a:spAutoFit/>
+          </a:bodyPr>
+          <a:lstStyle/>
+          <a:p>
+            <a:pPr algn="l"/>
+            <a:r>
+              <a:rPr sz="1050" b="1" i="0">
+                <a:solidFill>
+                  <a:srgbClr val="FFFFFF"/>
+                </a:solidFill>
+              </a:rPr>
+              <a:t>PASS</a:t>
+            </a:r>
+          </a:p>
+        </p:txBody>
+      </p:sp>
+      <p:sp>
+        <p:nvSpPr>
+          <p:cNvPr id="104" name="Rectangle 103"/>
+          <p:cNvSpPr/>
+          <p:nvPr/>
+        </p:nvSpPr>
+        <p:spPr>
+          <a:xfrm>
+            <a:off x="320040" y="3767328"/>
+            <a:ext cx="256032" cy="384048"/>
+          </a:xfrm>
+          <a:prstGeom prst="rect">
+            <a:avLst/>
+          </a:prstGeom>
+          <a:solidFill>
+            <a:srgbClr val="FFFFFF"/>
+          </a:solidFill>
+          <a:ln>
+            <a:noFill/>
+          </a:ln>
+        </p:spPr>
+        <p:style>
+          <a:lnRef idx="1">
+            <a:schemeClr val="accent1"/>
+          </a:lnRef>
+          <a:fillRef idx="3">
+            <a:schemeClr val="accent1"/>
+          </a:fillRef>
+          <a:effectRef idx="2">
+            <a:schemeClr val="accent1"/>
+          </a:effectRef>
+          <a:fontRef idx="minor">
+            <a:schemeClr val="lt1"/>
+          </a:fontRef>
+        </p:style>
+        <p:txBody>
+          <a:bodyPr rtlCol="0" anchor="ctr"/>
+          <a:lstStyle/>
+          <a:p>
+            <a:pPr algn="ctr"/>
+          </a:p>
+        </p:txBody>
+      </p:sp>
+      <p:sp>
+        <p:nvSpPr>
+          <p:cNvPr id="105" name="TextBox 104"/>
+          <p:cNvSpPr txBox="1"/>
+          <p:nvPr/>
+        </p:nvSpPr>
+        <p:spPr>
+          <a:xfrm>
+            <a:off x="365759" y="3840480"/>
+            <a:ext cx="182880" cy="292607"/>
+          </a:xfrm>
+          <a:prstGeom prst="rect">
+            <a:avLst/>
+          </a:prstGeom>
+          <a:noFill/>
+        </p:spPr>
+        <p:txBody>
+          <a:bodyPr wrap="none">
+            <a:spAutoFit/>
+          </a:bodyPr>
+          <a:lstStyle/>
+          <a:p>
+            <a:pPr algn="l"/>
+            <a:r>
+              <a:rPr sz="1050" b="0" i="0">
+                <a:solidFill>
+                  <a:srgbClr val="444E5C"/>
+                </a:solidFill>
+              </a:rPr>
+              <a:t>6</a:t>
+            </a:r>
+          </a:p>
+        </p:txBody>
+      </p:sp>
+      <p:sp>
+        <p:nvSpPr>
+          <p:cNvPr id="106" name="Rectangle 105"/>
+          <p:cNvSpPr/>
+          <p:nvPr/>
+        </p:nvSpPr>
+        <p:spPr>
+          <a:xfrm>
+            <a:off x="576072" y="3767328"/>
+            <a:ext cx="3017520" cy="384048"/>
+          </a:xfrm>
+          <a:prstGeom prst="rect">
+            <a:avLst/>
+          </a:prstGeom>
+          <a:solidFill>
+            <a:srgbClr val="FFFFFF"/>
+          </a:solidFill>
+          <a:ln>
+            <a:noFill/>
+          </a:ln>
+        </p:spPr>
+        <p:style>
+          <a:lnRef idx="1">
+            <a:schemeClr val="accent1"/>
+          </a:lnRef>
+          <a:fillRef idx="3">
+            <a:schemeClr val="accent1"/>
+          </a:fillRef>
+          <a:effectRef idx="2">
+            <a:schemeClr val="accent1"/>
+          </a:effectRef>
+          <a:fontRef idx="minor">
+            <a:schemeClr val="lt1"/>
+          </a:fontRef>
+        </p:style>
+        <p:txBody>
+          <a:bodyPr rtlCol="0" anchor="ctr"/>
+          <a:lstStyle/>
+          <a:p>
+            <a:pPr algn="ctr"/>
+          </a:p>
+        </p:txBody>
+      </p:sp>
+      <p:sp>
+        <p:nvSpPr>
+          <p:cNvPr id="107" name="TextBox 106"/>
+          <p:cNvSpPr txBox="1"/>
+          <p:nvPr/>
+        </p:nvSpPr>
+        <p:spPr>
+          <a:xfrm>
+            <a:off x="621792" y="3840480"/>
+            <a:ext cx="2944368" cy="292607"/>
+          </a:xfrm>
+          <a:prstGeom prst="rect">
+            <a:avLst/>
+          </a:prstGeom>
+          <a:noFill/>
+        </p:spPr>
+        <p:txBody>
+          <a:bodyPr wrap="none">
+            <a:spAutoFit/>
+          </a:bodyPr>
+          <a:lstStyle/>
+          <a:p>
+            <a:pPr algn="l"/>
+            <a:r>
+              <a:rPr sz="1050" b="0" i="0">
+                <a:solidFill>
+                  <a:srgbClr val="444E5C"/>
+                </a:solidFill>
+              </a:rPr>
+              <a:t>High Balance $67.5K–$136K + Clean DQ</a:t>
+            </a:r>
+          </a:p>
+        </p:txBody>
+      </p:sp>
+      <p:sp>
+        <p:nvSpPr>
+          <p:cNvPr id="108" name="Rectangle 107"/>
+          <p:cNvSpPr/>
+          <p:nvPr/>
+        </p:nvSpPr>
+        <p:spPr>
+          <a:xfrm>
+            <a:off x="3593591" y="3767328"/>
+            <a:ext cx="1234440" cy="384048"/>
+          </a:xfrm>
+          <a:prstGeom prst="rect">
+            <a:avLst/>
+          </a:prstGeom>
+          <a:solidFill>
+            <a:srgbClr val="FFFFFF"/>
+          </a:solidFill>
+          <a:ln>
+            <a:noFill/>
+          </a:ln>
+        </p:spPr>
+        <p:style>
+          <a:lnRef idx="1">
+            <a:schemeClr val="accent1"/>
+          </a:lnRef>
+          <a:fillRef idx="3">
+            <a:schemeClr val="accent1"/>
+          </a:fillRef>
+          <a:effectRef idx="2">
+            <a:schemeClr val="accent1"/>
+          </a:effectRef>
+          <a:fontRef idx="minor">
+            <a:schemeClr val="lt1"/>
+          </a:fontRef>
+        </p:style>
+        <p:txBody>
+          <a:bodyPr rtlCol="0" anchor="ctr"/>
+          <a:lstStyle/>
+          <a:p>
+            <a:pPr algn="ctr"/>
+          </a:p>
+        </p:txBody>
+      </p:sp>
+      <p:sp>
+        <p:nvSpPr>
+          <p:cNvPr id="109" name="TextBox 108"/>
+          <p:cNvSpPr txBox="1"/>
+          <p:nvPr/>
+        </p:nvSpPr>
+        <p:spPr>
+          <a:xfrm>
+            <a:off x="3639311" y="3840480"/>
+            <a:ext cx="1161288" cy="292607"/>
+          </a:xfrm>
+          <a:prstGeom prst="rect">
+            <a:avLst/>
+          </a:prstGeom>
+          <a:noFill/>
+        </p:spPr>
+        <p:txBody>
+          <a:bodyPr wrap="none">
+            <a:spAutoFit/>
+          </a:bodyPr>
+          <a:lstStyle/>
+          <a:p>
+            <a:pPr algn="l"/>
+            <a:r>
+              <a:rPr sz="1050" b="0" i="0">
+                <a:solidFill>
+                  <a:srgbClr val="007B83"/>
+                </a:solidFill>
+              </a:rPr>
+              <a:t>0.33%</a:t>
+            </a:r>
+          </a:p>
+        </p:txBody>
+      </p:sp>
+      <p:sp>
+        <p:nvSpPr>
+          <p:cNvPr id="110" name="Rectangle 109"/>
+          <p:cNvSpPr/>
+          <p:nvPr/>
+        </p:nvSpPr>
+        <p:spPr>
+          <a:xfrm>
+            <a:off x="4828031" y="3767328"/>
+            <a:ext cx="1234440" cy="384048"/>
+          </a:xfrm>
+          <a:prstGeom prst="rect">
+            <a:avLst/>
+          </a:prstGeom>
+          <a:solidFill>
+            <a:srgbClr val="FFFFFF"/>
+          </a:solidFill>
+          <a:ln>
+            <a:noFill/>
+          </a:ln>
+        </p:spPr>
+        <p:style>
+          <a:lnRef idx="1">
+            <a:schemeClr val="accent1"/>
+          </a:lnRef>
+          <a:fillRef idx="3">
+            <a:schemeClr val="accent1"/>
+          </a:fillRef>
+          <a:effectRef idx="2">
+            <a:schemeClr val="accent1"/>
+          </a:effectRef>
+          <a:fontRef idx="minor">
+            <a:schemeClr val="lt1"/>
+          </a:fontRef>
+        </p:style>
+        <p:txBody>
+          <a:bodyPr rtlCol="0" anchor="ctr"/>
+          <a:lstStyle/>
+          <a:p>
+            <a:pPr algn="ctr"/>
+          </a:p>
+        </p:txBody>
+      </p:sp>
+      <p:sp>
+        <p:nvSpPr>
+          <p:cNvPr id="111" name="TextBox 110"/>
+          <p:cNvSpPr txBox="1"/>
+          <p:nvPr/>
+        </p:nvSpPr>
+        <p:spPr>
+          <a:xfrm>
+            <a:off x="4873751" y="3840480"/>
+            <a:ext cx="1161288" cy="292607"/>
+          </a:xfrm>
+          <a:prstGeom prst="rect">
+            <a:avLst/>
+          </a:prstGeom>
+          <a:noFill/>
+        </p:spPr>
+        <p:txBody>
+          <a:bodyPr wrap="none">
+            <a:spAutoFit/>
+          </a:bodyPr>
+          <a:lstStyle/>
+          <a:p>
+            <a:pPr algn="l"/>
+            <a:r>
+              <a:rPr sz="1050" b="0" i="0">
+                <a:solidFill>
+                  <a:srgbClr val="007B83"/>
+                </a:solidFill>
+              </a:rPr>
+              <a:t>0.29%</a:t>
+            </a:r>
+          </a:p>
+        </p:txBody>
+      </p:sp>
+      <p:sp>
+        <p:nvSpPr>
+          <p:cNvPr id="112" name="Rectangle 111"/>
+          <p:cNvSpPr/>
+          <p:nvPr/>
+        </p:nvSpPr>
+        <p:spPr>
+          <a:xfrm>
+            <a:off x="6062471" y="3767328"/>
+            <a:ext cx="1234440" cy="384048"/>
+          </a:xfrm>
+          <a:prstGeom prst="rect">
+            <a:avLst/>
+          </a:prstGeom>
+          <a:solidFill>
+            <a:srgbClr val="FFFFFF"/>
+          </a:solidFill>
+          <a:ln>
+            <a:noFill/>
+          </a:ln>
+        </p:spPr>
+        <p:style>
+          <a:lnRef idx="1">
+            <a:schemeClr val="accent1"/>
+          </a:lnRef>
+          <a:fillRef idx="3">
+            <a:schemeClr val="accent1"/>
+          </a:fillRef>
+          <a:effectRef idx="2">
+            <a:schemeClr val="accent1"/>
+          </a:effectRef>
+          <a:fontRef idx="minor">
+            <a:schemeClr val="lt1"/>
+          </a:fontRef>
+        </p:style>
+        <p:txBody>
+          <a:bodyPr rtlCol="0" anchor="ctr"/>
+          <a:lstStyle/>
+          <a:p>
+            <a:pPr algn="ctr"/>
+          </a:p>
+        </p:txBody>
+      </p:sp>
+      <p:sp>
+        <p:nvSpPr>
+          <p:cNvPr id="113" name="TextBox 112"/>
+          <p:cNvSpPr txBox="1"/>
+          <p:nvPr/>
+        </p:nvSpPr>
+        <p:spPr>
+          <a:xfrm>
+            <a:off x="6108191" y="3840480"/>
+            <a:ext cx="1161288" cy="292607"/>
+          </a:xfrm>
+          <a:prstGeom prst="rect">
+            <a:avLst/>
+          </a:prstGeom>
+          <a:noFill/>
+        </p:spPr>
+        <p:txBody>
+          <a:bodyPr wrap="none">
+            <a:spAutoFit/>
+          </a:bodyPr>
+          <a:lstStyle/>
+          <a:p>
+            <a:pPr algn="l"/>
+            <a:r>
+              <a:rPr sz="1050" b="0" i="0">
+                <a:solidFill>
+                  <a:srgbClr val="007B83"/>
+                </a:solidFill>
+              </a:rPr>
+              <a:t>0.21%</a:t>
+            </a:r>
+          </a:p>
+        </p:txBody>
+      </p:sp>
+      <p:sp>
+        <p:nvSpPr>
+          <p:cNvPr id="114" name="Rectangle 113"/>
+          <p:cNvSpPr/>
+          <p:nvPr/>
+        </p:nvSpPr>
+        <p:spPr>
+          <a:xfrm>
+            <a:off x="7296911" y="3767328"/>
+            <a:ext cx="1005840" cy="384048"/>
+          </a:xfrm>
+          <a:prstGeom prst="rect">
+            <a:avLst/>
+          </a:prstGeom>
+          <a:solidFill>
+            <a:srgbClr val="FFFFFF"/>
+          </a:solidFill>
+          <a:ln>
+            <a:noFill/>
+          </a:ln>
+        </p:spPr>
+        <p:style>
+          <a:lnRef idx="1">
+            <a:schemeClr val="accent1"/>
+          </a:lnRef>
+          <a:fillRef idx="3">
+            <a:schemeClr val="accent1"/>
+          </a:fillRef>
+          <a:effectRef idx="2">
+            <a:schemeClr val="accent1"/>
+          </a:effectRef>
+          <a:fontRef idx="minor">
+            <a:schemeClr val="lt1"/>
+          </a:fontRef>
+        </p:style>
+        <p:txBody>
+          <a:bodyPr rtlCol="0" anchor="ctr"/>
+          <a:lstStyle/>
+          <a:p>
+            <a:pPr algn="ctr"/>
+          </a:p>
+        </p:txBody>
+      </p:sp>
+      <p:sp>
+        <p:nvSpPr>
+          <p:cNvPr id="115" name="TextBox 114"/>
+          <p:cNvSpPr txBox="1"/>
+          <p:nvPr/>
+        </p:nvSpPr>
+        <p:spPr>
+          <a:xfrm>
+            <a:off x="7342631" y="3840480"/>
+            <a:ext cx="932688" cy="292607"/>
+          </a:xfrm>
+          <a:prstGeom prst="rect">
+            <a:avLst/>
+          </a:prstGeom>
+          <a:noFill/>
+        </p:spPr>
+        <p:txBody>
+          <a:bodyPr wrap="none">
+            <a:spAutoFit/>
+          </a:bodyPr>
+          <a:lstStyle/>
+          <a:p>
+            <a:pPr algn="l"/>
+            <a:r>
+              <a:rPr sz="1050" b="1" i="0">
+                <a:solidFill>
+                  <a:srgbClr val="007B83"/>
+                </a:solidFill>
+              </a:rPr>
+              <a:t>0.28%</a:t>
+            </a:r>
+          </a:p>
+        </p:txBody>
+      </p:sp>
+      <p:sp>
+        <p:nvSpPr>
+          <p:cNvPr id="116" name="Rectangle 115"/>
+          <p:cNvSpPr/>
+          <p:nvPr/>
+        </p:nvSpPr>
+        <p:spPr>
+          <a:xfrm>
+            <a:off x="8302751" y="3767328"/>
+            <a:ext cx="713232" cy="384048"/>
+          </a:xfrm>
+          <a:prstGeom prst="rect">
+            <a:avLst/>
+          </a:prstGeom>
+          <a:solidFill>
+            <a:srgbClr val="FFFFFF"/>
+          </a:solidFill>
+          <a:ln>
+            <a:noFill/>
+          </a:ln>
+        </p:spPr>
+        <p:style>
+          <a:lnRef idx="1">
+            <a:schemeClr val="accent1"/>
+          </a:lnRef>
+          <a:fillRef idx="3">
+            <a:schemeClr val="accent1"/>
+          </a:fillRef>
+          <a:effectRef idx="2">
+            <a:schemeClr val="accent1"/>
+          </a:effectRef>
+          <a:fontRef idx="minor">
+            <a:schemeClr val="lt1"/>
+          </a:fontRef>
+        </p:style>
+        <p:txBody>
+          <a:bodyPr rtlCol="0" anchor="ctr"/>
+          <a:lstStyle/>
+          <a:p>
+            <a:pPr algn="ctr"/>
+          </a:p>
+        </p:txBody>
+      </p:sp>
+      <p:sp>
+        <p:nvSpPr>
+          <p:cNvPr id="117" name="TextBox 116"/>
+          <p:cNvSpPr txBox="1"/>
+          <p:nvPr/>
+        </p:nvSpPr>
+        <p:spPr>
+          <a:xfrm>
+            <a:off x="8348471" y="3840480"/>
+            <a:ext cx="640080" cy="292607"/>
+          </a:xfrm>
+          <a:prstGeom prst="rect">
+            <a:avLst/>
+          </a:prstGeom>
+          <a:noFill/>
+        </p:spPr>
+        <p:txBody>
+          <a:bodyPr wrap="none">
+            <a:spAutoFit/>
+          </a:bodyPr>
+          <a:lstStyle/>
+          <a:p>
+            <a:pPr algn="l"/>
+            <a:r>
+              <a:rPr sz="1050" b="0" i="0">
+                <a:solidFill>
+                  <a:srgbClr val="CCD1D9"/>
+                </a:solidFill>
+              </a:rPr>
+              <a:t>0.41%</a:t>
+            </a:r>
+          </a:p>
+        </p:txBody>
+      </p:sp>
+      <p:sp>
+        <p:nvSpPr>
+          <p:cNvPr id="118" name="Rectangle 117"/>
+          <p:cNvSpPr/>
+          <p:nvPr/>
+        </p:nvSpPr>
+        <p:spPr>
+          <a:xfrm>
+            <a:off x="9015983" y="3767328"/>
+            <a:ext cx="722376" cy="384048"/>
+          </a:xfrm>
+          <a:prstGeom prst="rect">
+            <a:avLst/>
+          </a:prstGeom>
+          <a:solidFill>
+            <a:srgbClr val="2E7D32"/>
+          </a:solidFill>
+          <a:ln>
+            <a:noFill/>
+          </a:ln>
+        </p:spPr>
+        <p:style>
+          <a:lnRef idx="1">
+            <a:schemeClr val="accent1"/>
+          </a:lnRef>
+          <a:fillRef idx="3">
+            <a:schemeClr val="accent1"/>
+          </a:fillRef>
+          <a:effectRef idx="2">
+            <a:schemeClr val="accent1"/>
+          </a:effectRef>
+          <a:fontRef idx="minor">
+            <a:schemeClr val="lt1"/>
+          </a:fontRef>
+        </p:style>
+        <p:txBody>
+          <a:bodyPr rtlCol="0" anchor="ctr"/>
+          <a:lstStyle/>
+          <a:p>
+            <a:pPr algn="ctr"/>
+          </a:p>
+        </p:txBody>
+      </p:sp>
+      <p:sp>
+        <p:nvSpPr>
+          <p:cNvPr id="119" name="TextBox 118"/>
+          <p:cNvSpPr txBox="1"/>
+          <p:nvPr/>
+        </p:nvSpPr>
+        <p:spPr>
+          <a:xfrm>
+            <a:off x="9061703" y="3840480"/>
+            <a:ext cx="649224" cy="292607"/>
+          </a:xfrm>
+          <a:prstGeom prst="rect">
+            <a:avLst/>
+          </a:prstGeom>
+          <a:noFill/>
+        </p:spPr>
+        <p:txBody>
+          <a:bodyPr wrap="none">
+            <a:spAutoFit/>
+          </a:bodyPr>
+          <a:lstStyle/>
+          <a:p>
+            <a:pPr algn="l"/>
+            <a:r>
+              <a:rPr sz="1050" b="1" i="0">
+                <a:solidFill>
+                  <a:srgbClr val="FFFFFF"/>
+                </a:solidFill>
+              </a:rPr>
+              <a:t>PASS</a:t>
+            </a:r>
+          </a:p>
+        </p:txBody>
+      </p:sp>
+      <p:sp>
+        <p:nvSpPr>
+          <p:cNvPr id="120" name="Rectangle 119"/>
+          <p:cNvSpPr/>
+          <p:nvPr/>
+        </p:nvSpPr>
+        <p:spPr>
+          <a:xfrm>
+            <a:off x="320040" y="4709160"/>
+            <a:ext cx="11548872" cy="384048"/>
+          </a:xfrm>
+          <a:prstGeom prst="rect">
+            <a:avLst/>
+          </a:prstGeom>
+          <a:solidFill>
+            <a:srgbClr val="E8F5E9"/>
+          </a:solidFill>
+          <a:ln>
+            <a:noFill/>
+          </a:ln>
+        </p:spPr>
+        <p:style>
+          <a:lnRef idx="1">
+            <a:schemeClr val="accent1"/>
+          </a:lnRef>
+          <a:fillRef idx="3">
+            <a:schemeClr val="accent1"/>
+          </a:fillRef>
+          <a:effectRef idx="2">
+            <a:schemeClr val="accent1"/>
+          </a:effectRef>
+          <a:fontRef idx="minor">
+            <a:schemeClr val="lt1"/>
+          </a:fontRef>
+        </p:style>
+        <p:txBody>
+          <a:bodyPr rtlCol="0" anchor="ctr"/>
+          <a:lstStyle/>
+          <a:p>
+            <a:pPr algn="ctr"/>
+          </a:p>
+        </p:txBody>
+      </p:sp>
+      <p:sp>
+        <p:nvSpPr>
+          <p:cNvPr id="121" name="TextBox 120"/>
+          <p:cNvSpPr txBox="1"/>
+          <p:nvPr/>
+        </p:nvSpPr>
+        <p:spPr>
+          <a:xfrm>
+            <a:off x="457200" y="4754880"/>
+            <a:ext cx="11292840" cy="292608"/>
+          </a:xfrm>
+          <a:prstGeom prst="rect">
+            <a:avLst/>
+          </a:prstGeom>
+          <a:noFill/>
+        </p:spPr>
+        <p:txBody>
+          <a:bodyPr wrap="none">
+            <a:spAutoFit/>
+          </a:bodyPr>
+          <a:lstStyle/>
+          <a:p>
+            <a:pPr algn="l"/>
+            <a:r>
+              <a:rPr sz="1100" b="1" i="0">
+                <a:solidFill>
+                  <a:srgbClr val="2E7D32"/>
+                </a:solidFill>
+              </a:rPr>
+              <a:t>Pass criterion: all individual wave rates AND overall rate &lt; BAU (0.41%).  All 6 / 6 segments pass. Rates range 0.19%–0.33% across all waves.</a:t>
             </a:r>
           </a:p>
         </p:txBody>

</xml_diff>